<commit_message>
Add current/total page number to bottom-right of every slide
- stamp_pages() post-pass: 'Day N · 요일 · i / N' bottom-right on all slides
- bg-aware color (light slate on navy, muted on white); footer left text kept

Co-Authored-By: Claude Opus 4.8 <noreply@anthropic.com>
</commit_message>
<xml_diff>
--- a/slides/day5.pptx
+++ b/slides/day5.pptx
@@ -3983,6 +3983,64 @@
           </a:p>
         </p:txBody>
       </p:sp>
+      <p:sp>
+        <p:nvSpPr>
+          <p:cNvPr id="21" name="TextBox 20"/>
+          <p:cNvSpPr txBox="1"/>
+          <p:nvPr/>
+        </p:nvSpPr>
+        <p:spPr>
+          <a:xfrm>
+            <a:off x="8988552" y="6419088"/>
+            <a:ext cx="2697480" cy="365760"/>
+          </a:xfrm>
+          <a:prstGeom prst="rect">
+            <a:avLst/>
+          </a:prstGeom>
+          <a:noFill/>
+        </p:spPr>
+        <p:txBody>
+          <a:bodyPr wrap="square" anchor="ctr" lIns="0" rIns="0" tIns="0" bIns="0">
+            <a:spAutoFit/>
+          </a:bodyPr>
+          <a:lstStyle/>
+          <a:p>
+            <a:pPr algn="r">
+              <a:lnSpc>
+                <a:spcPct val="100000"/>
+              </a:lnSpc>
+              <a:spcBef>
+                <a:spcPts val="0"/>
+              </a:spcBef>
+              <a:spcAft>
+                <a:spcPts val="600"/>
+              </a:spcAft>
+            </a:pPr>
+            <a:r>
+              <a:rPr sz="900" b="1">
+                <a:solidFill>
+                  <a:srgbClr val="F43F5E"/>
+                </a:solidFill>
+                <a:latin typeface="NanumGothic"/>
+                <a:ea typeface="NanumGothic"/>
+                <a:cs typeface="NanumGothic"/>
+              </a:rPr>
+              <a:t>Day 5 · 금</a:t>
+            </a:r>
+            <a:r>
+              <a:rPr sz="900" b="1">
+                <a:solidFill>
+                  <a:srgbClr val="CBD5E1"/>
+                </a:solidFill>
+                <a:latin typeface="NanumGothic"/>
+                <a:ea typeface="NanumGothic"/>
+                <a:cs typeface="NanumGothic"/>
+              </a:rPr>
+              <a:t>   ·   1 / 21</a:t>
+            </a:r>
+          </a:p>
+        </p:txBody>
+      </p:sp>
     </p:spTree>
   </p:cSld>
   <p:clrMapOvr>
@@ -4276,54 +4334,7 @@
       </p:sp>
       <p:sp>
         <p:nvSpPr>
-          <p:cNvPr id="8" name="TextBox 7"/>
-          <p:cNvSpPr txBox="1"/>
-          <p:nvPr/>
-        </p:nvSpPr>
-        <p:spPr>
-          <a:xfrm>
-            <a:off x="10241280" y="6419088"/>
-            <a:ext cx="1463040" cy="365760"/>
-          </a:xfrm>
-          <a:prstGeom prst="rect">
-            <a:avLst/>
-          </a:prstGeom>
-          <a:noFill/>
-        </p:spPr>
-        <p:txBody>
-          <a:bodyPr wrap="square" anchor="ctr" lIns="0" rIns="0" tIns="0" bIns="0">
-            <a:spAutoFit/>
-          </a:bodyPr>
-          <a:lstStyle/>
-          <a:p>
-            <a:pPr algn="r">
-              <a:lnSpc>
-                <a:spcPct val="100000"/>
-              </a:lnSpc>
-              <a:spcBef>
-                <a:spcPts val="0"/>
-              </a:spcBef>
-              <a:spcAft>
-                <a:spcPts val="600"/>
-              </a:spcAft>
-            </a:pPr>
-            <a:r>
-              <a:rPr sz="900" b="1">
-                <a:solidFill>
-                  <a:srgbClr val="F43F5E"/>
-                </a:solidFill>
-                <a:latin typeface="NanumGothic"/>
-                <a:ea typeface="NanumGothic"/>
-                <a:cs typeface="NanumGothic"/>
-              </a:rPr>
-              <a:t>Day 5 · 금</a:t>
-            </a:r>
-          </a:p>
-        </p:txBody>
-      </p:sp>
-      <p:sp>
-        <p:nvSpPr>
-          <p:cNvPr id="9" name="Rounded Rectangle 8"/>
+          <p:cNvPr id="8" name="Rounded Rectangle 7"/>
           <p:cNvSpPr/>
           <p:nvPr/>
         </p:nvSpPr>
@@ -4369,7 +4380,7 @@
       </p:sp>
       <p:sp>
         <p:nvSpPr>
-          <p:cNvPr id="10" name="TextBox 9"/>
+          <p:cNvPr id="9" name="TextBox 8"/>
           <p:cNvSpPr txBox="1"/>
           <p:nvPr/>
         </p:nvSpPr>
@@ -4416,7 +4427,7 @@
       </p:sp>
       <p:sp>
         <p:nvSpPr>
-          <p:cNvPr id="11" name="TextBox 10"/>
+          <p:cNvPr id="10" name="TextBox 9"/>
           <p:cNvSpPr txBox="1"/>
           <p:nvPr/>
         </p:nvSpPr>
@@ -4463,7 +4474,7 @@
       </p:sp>
       <p:sp>
         <p:nvSpPr>
-          <p:cNvPr id="12" name="Rounded Rectangle 11"/>
+          <p:cNvPr id="11" name="Rounded Rectangle 10"/>
           <p:cNvSpPr/>
           <p:nvPr/>
         </p:nvSpPr>
@@ -4509,7 +4520,7 @@
       </p:sp>
       <p:sp>
         <p:nvSpPr>
-          <p:cNvPr id="13" name="Oval 12"/>
+          <p:cNvPr id="12" name="Oval 11"/>
           <p:cNvSpPr/>
           <p:nvPr/>
         </p:nvSpPr>
@@ -4553,7 +4564,7 @@
       </p:sp>
       <p:sp>
         <p:nvSpPr>
-          <p:cNvPr id="14" name="TextBox 13"/>
+          <p:cNvPr id="13" name="TextBox 12"/>
           <p:cNvSpPr txBox="1"/>
           <p:nvPr/>
         </p:nvSpPr>
@@ -4600,7 +4611,7 @@
       </p:sp>
       <p:sp>
         <p:nvSpPr>
-          <p:cNvPr id="15" name="TextBox 14"/>
+          <p:cNvPr id="14" name="TextBox 13"/>
           <p:cNvSpPr txBox="1"/>
           <p:nvPr/>
         </p:nvSpPr>
@@ -4647,7 +4658,7 @@
       </p:sp>
       <p:sp>
         <p:nvSpPr>
-          <p:cNvPr id="16" name="Rounded Rectangle 15"/>
+          <p:cNvPr id="15" name="Rounded Rectangle 14"/>
           <p:cNvSpPr/>
           <p:nvPr/>
         </p:nvSpPr>
@@ -4693,7 +4704,7 @@
       </p:sp>
       <p:sp>
         <p:nvSpPr>
-          <p:cNvPr id="17" name="Oval 16"/>
+          <p:cNvPr id="16" name="Oval 15"/>
           <p:cNvSpPr/>
           <p:nvPr/>
         </p:nvSpPr>
@@ -4737,7 +4748,7 @@
       </p:sp>
       <p:sp>
         <p:nvSpPr>
-          <p:cNvPr id="18" name="TextBox 17"/>
+          <p:cNvPr id="17" name="TextBox 16"/>
           <p:cNvSpPr txBox="1"/>
           <p:nvPr/>
         </p:nvSpPr>
@@ -4784,7 +4795,7 @@
       </p:sp>
       <p:sp>
         <p:nvSpPr>
-          <p:cNvPr id="19" name="TextBox 18"/>
+          <p:cNvPr id="18" name="TextBox 17"/>
           <p:cNvSpPr txBox="1"/>
           <p:nvPr/>
         </p:nvSpPr>
@@ -4831,7 +4842,7 @@
       </p:sp>
       <p:sp>
         <p:nvSpPr>
-          <p:cNvPr id="20" name="Rounded Rectangle 19"/>
+          <p:cNvPr id="19" name="Rounded Rectangle 18"/>
           <p:cNvSpPr/>
           <p:nvPr/>
         </p:nvSpPr>
@@ -4877,7 +4888,7 @@
       </p:sp>
       <p:sp>
         <p:nvSpPr>
-          <p:cNvPr id="21" name="Oval 20"/>
+          <p:cNvPr id="20" name="Oval 19"/>
           <p:cNvSpPr/>
           <p:nvPr/>
         </p:nvSpPr>
@@ -4921,7 +4932,7 @@
       </p:sp>
       <p:sp>
         <p:nvSpPr>
-          <p:cNvPr id="22" name="TextBox 21"/>
+          <p:cNvPr id="21" name="TextBox 20"/>
           <p:cNvSpPr txBox="1"/>
           <p:nvPr/>
         </p:nvSpPr>
@@ -4968,7 +4979,7 @@
       </p:sp>
       <p:sp>
         <p:nvSpPr>
-          <p:cNvPr id="23" name="TextBox 22"/>
+          <p:cNvPr id="22" name="TextBox 21"/>
           <p:cNvSpPr txBox="1"/>
           <p:nvPr/>
         </p:nvSpPr>
@@ -5015,7 +5026,7 @@
       </p:sp>
       <p:sp>
         <p:nvSpPr>
-          <p:cNvPr id="24" name="Rounded Rectangle 23"/>
+          <p:cNvPr id="23" name="Rounded Rectangle 22"/>
           <p:cNvSpPr/>
           <p:nvPr/>
         </p:nvSpPr>
@@ -5061,7 +5072,7 @@
       </p:sp>
       <p:sp>
         <p:nvSpPr>
-          <p:cNvPr id="25" name="Oval 24"/>
+          <p:cNvPr id="24" name="Oval 23"/>
           <p:cNvSpPr/>
           <p:nvPr/>
         </p:nvSpPr>
@@ -5105,7 +5116,7 @@
       </p:sp>
       <p:sp>
         <p:nvSpPr>
-          <p:cNvPr id="26" name="TextBox 25"/>
+          <p:cNvPr id="25" name="TextBox 24"/>
           <p:cNvSpPr txBox="1"/>
           <p:nvPr/>
         </p:nvSpPr>
@@ -5152,7 +5163,7 @@
       </p:sp>
       <p:sp>
         <p:nvSpPr>
-          <p:cNvPr id="27" name="TextBox 26"/>
+          <p:cNvPr id="26" name="TextBox 25"/>
           <p:cNvSpPr txBox="1"/>
           <p:nvPr/>
         </p:nvSpPr>
@@ -5199,7 +5210,7 @@
       </p:sp>
       <p:sp>
         <p:nvSpPr>
-          <p:cNvPr id="28" name="Rounded Rectangle 27"/>
+          <p:cNvPr id="27" name="Rounded Rectangle 26"/>
           <p:cNvSpPr/>
           <p:nvPr/>
         </p:nvSpPr>
@@ -5245,7 +5256,7 @@
       </p:sp>
       <p:sp>
         <p:nvSpPr>
-          <p:cNvPr id="29" name="Oval 28"/>
+          <p:cNvPr id="28" name="Oval 27"/>
           <p:cNvSpPr/>
           <p:nvPr/>
         </p:nvSpPr>
@@ -5289,7 +5300,7 @@
       </p:sp>
       <p:sp>
         <p:nvSpPr>
-          <p:cNvPr id="30" name="TextBox 29"/>
+          <p:cNvPr id="29" name="TextBox 28"/>
           <p:cNvSpPr txBox="1"/>
           <p:nvPr/>
         </p:nvSpPr>
@@ -5336,7 +5347,7 @@
       </p:sp>
       <p:sp>
         <p:nvSpPr>
-          <p:cNvPr id="31" name="TextBox 30"/>
+          <p:cNvPr id="30" name="TextBox 29"/>
           <p:cNvSpPr txBox="1"/>
           <p:nvPr/>
         </p:nvSpPr>
@@ -5383,7 +5394,7 @@
       </p:sp>
       <p:sp>
         <p:nvSpPr>
-          <p:cNvPr id="32" name="Rounded Rectangle 31"/>
+          <p:cNvPr id="31" name="Rounded Rectangle 30"/>
           <p:cNvSpPr/>
           <p:nvPr/>
         </p:nvSpPr>
@@ -5429,7 +5440,7 @@
       </p:sp>
       <p:sp>
         <p:nvSpPr>
-          <p:cNvPr id="33" name="Oval 32"/>
+          <p:cNvPr id="32" name="Oval 31"/>
           <p:cNvSpPr/>
           <p:nvPr/>
         </p:nvSpPr>
@@ -5473,7 +5484,7 @@
       </p:sp>
       <p:sp>
         <p:nvSpPr>
-          <p:cNvPr id="34" name="TextBox 33"/>
+          <p:cNvPr id="33" name="TextBox 32"/>
           <p:cNvSpPr txBox="1"/>
           <p:nvPr/>
         </p:nvSpPr>
@@ -5520,7 +5531,7 @@
       </p:sp>
       <p:sp>
         <p:nvSpPr>
-          <p:cNvPr id="35" name="TextBox 34"/>
+          <p:cNvPr id="34" name="TextBox 33"/>
           <p:cNvSpPr txBox="1"/>
           <p:nvPr/>
         </p:nvSpPr>
@@ -5561,6 +5572,64 @@
                 <a:cs typeface="NanumGothic"/>
               </a:rPr>
               <a:t>제안서·발표자료 제작(실습)</a:t>
+            </a:r>
+          </a:p>
+        </p:txBody>
+      </p:sp>
+      <p:sp>
+        <p:nvSpPr>
+          <p:cNvPr id="35" name="TextBox 34"/>
+          <p:cNvSpPr txBox="1"/>
+          <p:nvPr/>
+        </p:nvSpPr>
+        <p:spPr>
+          <a:xfrm>
+            <a:off x="8988552" y="6419088"/>
+            <a:ext cx="2697480" cy="365760"/>
+          </a:xfrm>
+          <a:prstGeom prst="rect">
+            <a:avLst/>
+          </a:prstGeom>
+          <a:noFill/>
+        </p:spPr>
+        <p:txBody>
+          <a:bodyPr wrap="square" anchor="ctr" lIns="0" rIns="0" tIns="0" bIns="0">
+            <a:spAutoFit/>
+          </a:bodyPr>
+          <a:lstStyle/>
+          <a:p>
+            <a:pPr algn="r">
+              <a:lnSpc>
+                <a:spcPct val="100000"/>
+              </a:lnSpc>
+              <a:spcBef>
+                <a:spcPts val="0"/>
+              </a:spcBef>
+              <a:spcAft>
+                <a:spcPts val="600"/>
+              </a:spcAft>
+            </a:pPr>
+            <a:r>
+              <a:rPr sz="900" b="1">
+                <a:solidFill>
+                  <a:srgbClr val="F43F5E"/>
+                </a:solidFill>
+                <a:latin typeface="NanumGothic"/>
+                <a:ea typeface="NanumGothic"/>
+                <a:cs typeface="NanumGothic"/>
+              </a:rPr>
+              <a:t>Day 5 · 금</a:t>
+            </a:r>
+            <a:r>
+              <a:rPr sz="900" b="1">
+                <a:solidFill>
+                  <a:srgbClr val="64748B"/>
+                </a:solidFill>
+                <a:latin typeface="NanumGothic"/>
+                <a:ea typeface="NanumGothic"/>
+                <a:cs typeface="NanumGothic"/>
+              </a:rPr>
+              <a:t>   ·   10 / 21</a:t>
             </a:r>
           </a:p>
         </p:txBody>
@@ -5858,54 +5927,7 @@
       </p:sp>
       <p:sp>
         <p:nvSpPr>
-          <p:cNvPr id="8" name="TextBox 7"/>
-          <p:cNvSpPr txBox="1"/>
-          <p:nvPr/>
-        </p:nvSpPr>
-        <p:spPr>
-          <a:xfrm>
-            <a:off x="10241280" y="6419088"/>
-            <a:ext cx="1463040" cy="365760"/>
-          </a:xfrm>
-          <a:prstGeom prst="rect">
-            <a:avLst/>
-          </a:prstGeom>
-          <a:noFill/>
-        </p:spPr>
-        <p:txBody>
-          <a:bodyPr wrap="square" anchor="ctr" lIns="0" rIns="0" tIns="0" bIns="0">
-            <a:spAutoFit/>
-          </a:bodyPr>
-          <a:lstStyle/>
-          <a:p>
-            <a:pPr algn="r">
-              <a:lnSpc>
-                <a:spcPct val="100000"/>
-              </a:lnSpc>
-              <a:spcBef>
-                <a:spcPts val="0"/>
-              </a:spcBef>
-              <a:spcAft>
-                <a:spcPts val="600"/>
-              </a:spcAft>
-            </a:pPr>
-            <a:r>
-              <a:rPr sz="900" b="1">
-                <a:solidFill>
-                  <a:srgbClr val="F43F5E"/>
-                </a:solidFill>
-                <a:latin typeface="NanumGothic"/>
-                <a:ea typeface="NanumGothic"/>
-                <a:cs typeface="NanumGothic"/>
-              </a:rPr>
-              <a:t>Day 5 · 금</a:t>
-            </a:r>
-          </a:p>
-        </p:txBody>
-      </p:sp>
-      <p:sp>
-        <p:nvSpPr>
-          <p:cNvPr id="9" name="Oval 8"/>
+          <p:cNvPr id="8" name="Oval 7"/>
           <p:cNvSpPr/>
           <p:nvPr/>
         </p:nvSpPr>
@@ -5949,7 +5971,7 @@
       </p:sp>
       <p:sp>
         <p:nvSpPr>
-          <p:cNvPr id="10" name="TextBox 9"/>
+          <p:cNvPr id="9" name="TextBox 8"/>
           <p:cNvSpPr txBox="1"/>
           <p:nvPr/>
         </p:nvSpPr>
@@ -5996,7 +6018,7 @@
       </p:sp>
       <p:sp>
         <p:nvSpPr>
-          <p:cNvPr id="11" name="TextBox 10"/>
+          <p:cNvPr id="10" name="TextBox 9"/>
           <p:cNvSpPr txBox="1"/>
           <p:nvPr/>
         </p:nvSpPr>
@@ -6043,7 +6065,7 @@
       </p:sp>
       <p:sp>
         <p:nvSpPr>
-          <p:cNvPr id="12" name="Oval 11"/>
+          <p:cNvPr id="11" name="Oval 10"/>
           <p:cNvSpPr/>
           <p:nvPr/>
         </p:nvSpPr>
@@ -6087,7 +6109,7 @@
       </p:sp>
       <p:sp>
         <p:nvSpPr>
-          <p:cNvPr id="13" name="TextBox 12"/>
+          <p:cNvPr id="12" name="TextBox 11"/>
           <p:cNvSpPr txBox="1"/>
           <p:nvPr/>
         </p:nvSpPr>
@@ -6134,7 +6156,7 @@
       </p:sp>
       <p:sp>
         <p:nvSpPr>
-          <p:cNvPr id="14" name="TextBox 13"/>
+          <p:cNvPr id="13" name="TextBox 12"/>
           <p:cNvSpPr txBox="1"/>
           <p:nvPr/>
         </p:nvSpPr>
@@ -6181,7 +6203,7 @@
       </p:sp>
       <p:sp>
         <p:nvSpPr>
-          <p:cNvPr id="15" name="Oval 14"/>
+          <p:cNvPr id="14" name="Oval 13"/>
           <p:cNvSpPr/>
           <p:nvPr/>
         </p:nvSpPr>
@@ -6225,7 +6247,7 @@
       </p:sp>
       <p:sp>
         <p:nvSpPr>
-          <p:cNvPr id="16" name="TextBox 15"/>
+          <p:cNvPr id="15" name="TextBox 14"/>
           <p:cNvSpPr txBox="1"/>
           <p:nvPr/>
         </p:nvSpPr>
@@ -6272,7 +6294,7 @@
       </p:sp>
       <p:sp>
         <p:nvSpPr>
-          <p:cNvPr id="17" name="TextBox 16"/>
+          <p:cNvPr id="16" name="TextBox 15"/>
           <p:cNvSpPr txBox="1"/>
           <p:nvPr/>
         </p:nvSpPr>
@@ -6313,6 +6335,64 @@
                 <a:cs typeface="NanumGothic"/>
               </a:rPr>
               <a:t>초안은 AI, 판단·검증은 사람</a:t>
+            </a:r>
+          </a:p>
+        </p:txBody>
+      </p:sp>
+      <p:sp>
+        <p:nvSpPr>
+          <p:cNvPr id="17" name="TextBox 16"/>
+          <p:cNvSpPr txBox="1"/>
+          <p:nvPr/>
+        </p:nvSpPr>
+        <p:spPr>
+          <a:xfrm>
+            <a:off x="8988552" y="6419088"/>
+            <a:ext cx="2697480" cy="365760"/>
+          </a:xfrm>
+          <a:prstGeom prst="rect">
+            <a:avLst/>
+          </a:prstGeom>
+          <a:noFill/>
+        </p:spPr>
+        <p:txBody>
+          <a:bodyPr wrap="square" anchor="ctr" lIns="0" rIns="0" tIns="0" bIns="0">
+            <a:spAutoFit/>
+          </a:bodyPr>
+          <a:lstStyle/>
+          <a:p>
+            <a:pPr algn="r">
+              <a:lnSpc>
+                <a:spcPct val="100000"/>
+              </a:lnSpc>
+              <a:spcBef>
+                <a:spcPts val="0"/>
+              </a:spcBef>
+              <a:spcAft>
+                <a:spcPts val="600"/>
+              </a:spcAft>
+            </a:pPr>
+            <a:r>
+              <a:rPr sz="900" b="1">
+                <a:solidFill>
+                  <a:srgbClr val="F43F5E"/>
+                </a:solidFill>
+                <a:latin typeface="NanumGothic"/>
+                <a:ea typeface="NanumGothic"/>
+                <a:cs typeface="NanumGothic"/>
+              </a:rPr>
+              <a:t>Day 5 · 금</a:t>
+            </a:r>
+            <a:r>
+              <a:rPr sz="900" b="1">
+                <a:solidFill>
+                  <a:srgbClr val="64748B"/>
+                </a:solidFill>
+                <a:latin typeface="NanumGothic"/>
+                <a:ea typeface="NanumGothic"/>
+                <a:cs typeface="NanumGothic"/>
+              </a:rPr>
+              <a:t>   ·   11 / 21</a:t>
             </a:r>
           </a:p>
         </p:txBody>
@@ -6610,54 +6690,7 @@
       </p:sp>
       <p:sp>
         <p:nvSpPr>
-          <p:cNvPr id="8" name="TextBox 7"/>
-          <p:cNvSpPr txBox="1"/>
-          <p:nvPr/>
-        </p:nvSpPr>
-        <p:spPr>
-          <a:xfrm>
-            <a:off x="10241280" y="6419088"/>
-            <a:ext cx="1463040" cy="365760"/>
-          </a:xfrm>
-          <a:prstGeom prst="rect">
-            <a:avLst/>
-          </a:prstGeom>
-          <a:noFill/>
-        </p:spPr>
-        <p:txBody>
-          <a:bodyPr wrap="square" anchor="ctr" lIns="0" rIns="0" tIns="0" bIns="0">
-            <a:spAutoFit/>
-          </a:bodyPr>
-          <a:lstStyle/>
-          <a:p>
-            <a:pPr algn="r">
-              <a:lnSpc>
-                <a:spcPct val="100000"/>
-              </a:lnSpc>
-              <a:spcBef>
-                <a:spcPts val="0"/>
-              </a:spcBef>
-              <a:spcAft>
-                <a:spcPts val="600"/>
-              </a:spcAft>
-            </a:pPr>
-            <a:r>
-              <a:rPr sz="900" b="1">
-                <a:solidFill>
-                  <a:srgbClr val="F43F5E"/>
-                </a:solidFill>
-                <a:latin typeface="NanumGothic"/>
-                <a:ea typeface="NanumGothic"/>
-                <a:cs typeface="NanumGothic"/>
-              </a:rPr>
-              <a:t>Day 5 · 금</a:t>
-            </a:r>
-          </a:p>
-        </p:txBody>
-      </p:sp>
-      <p:sp>
-        <p:nvSpPr>
-          <p:cNvPr id="9" name="Oval 8"/>
+          <p:cNvPr id="8" name="Oval 7"/>
           <p:cNvSpPr/>
           <p:nvPr/>
         </p:nvSpPr>
@@ -6701,7 +6734,7 @@
       </p:sp>
       <p:sp>
         <p:nvSpPr>
-          <p:cNvPr id="10" name="TextBox 9"/>
+          <p:cNvPr id="9" name="TextBox 8"/>
           <p:cNvSpPr txBox="1"/>
           <p:nvPr/>
         </p:nvSpPr>
@@ -6748,7 +6781,7 @@
       </p:sp>
       <p:sp>
         <p:nvSpPr>
-          <p:cNvPr id="11" name="TextBox 10"/>
+          <p:cNvPr id="10" name="TextBox 9"/>
           <p:cNvSpPr txBox="1"/>
           <p:nvPr/>
         </p:nvSpPr>
@@ -6795,7 +6828,7 @@
       </p:sp>
       <p:sp>
         <p:nvSpPr>
-          <p:cNvPr id="12" name="Oval 11"/>
+          <p:cNvPr id="11" name="Oval 10"/>
           <p:cNvSpPr/>
           <p:nvPr/>
         </p:nvSpPr>
@@ -6839,7 +6872,7 @@
       </p:sp>
       <p:sp>
         <p:nvSpPr>
-          <p:cNvPr id="13" name="TextBox 12"/>
+          <p:cNvPr id="12" name="TextBox 11"/>
           <p:cNvSpPr txBox="1"/>
           <p:nvPr/>
         </p:nvSpPr>
@@ -6886,7 +6919,7 @@
       </p:sp>
       <p:sp>
         <p:nvSpPr>
-          <p:cNvPr id="14" name="TextBox 13"/>
+          <p:cNvPr id="13" name="TextBox 12"/>
           <p:cNvSpPr txBox="1"/>
           <p:nvPr/>
         </p:nvSpPr>
@@ -6933,7 +6966,7 @@
       </p:sp>
       <p:sp>
         <p:nvSpPr>
-          <p:cNvPr id="15" name="Oval 14"/>
+          <p:cNvPr id="14" name="Oval 13"/>
           <p:cNvSpPr/>
           <p:nvPr/>
         </p:nvSpPr>
@@ -6977,7 +7010,7 @@
       </p:sp>
       <p:sp>
         <p:nvSpPr>
-          <p:cNvPr id="16" name="TextBox 15"/>
+          <p:cNvPr id="15" name="TextBox 14"/>
           <p:cNvSpPr txBox="1"/>
           <p:nvPr/>
         </p:nvSpPr>
@@ -7024,7 +7057,7 @@
       </p:sp>
       <p:sp>
         <p:nvSpPr>
-          <p:cNvPr id="17" name="TextBox 16"/>
+          <p:cNvPr id="16" name="TextBox 15"/>
           <p:cNvSpPr txBox="1"/>
           <p:nvPr/>
         </p:nvSpPr>
@@ -7065,6 +7098,64 @@
                 <a:cs typeface="NanumGothic"/>
               </a:rPr>
               <a:t>신뢰</a:t>
+            </a:r>
+          </a:p>
+        </p:txBody>
+      </p:sp>
+      <p:sp>
+        <p:nvSpPr>
+          <p:cNvPr id="17" name="TextBox 16"/>
+          <p:cNvSpPr txBox="1"/>
+          <p:nvPr/>
+        </p:nvSpPr>
+        <p:spPr>
+          <a:xfrm>
+            <a:off x="8988552" y="6419088"/>
+            <a:ext cx="2697480" cy="365760"/>
+          </a:xfrm>
+          <a:prstGeom prst="rect">
+            <a:avLst/>
+          </a:prstGeom>
+          <a:noFill/>
+        </p:spPr>
+        <p:txBody>
+          <a:bodyPr wrap="square" anchor="ctr" lIns="0" rIns="0" tIns="0" bIns="0">
+            <a:spAutoFit/>
+          </a:bodyPr>
+          <a:lstStyle/>
+          <a:p>
+            <a:pPr algn="r">
+              <a:lnSpc>
+                <a:spcPct val="100000"/>
+              </a:lnSpc>
+              <a:spcBef>
+                <a:spcPts val="0"/>
+              </a:spcBef>
+              <a:spcAft>
+                <a:spcPts val="600"/>
+              </a:spcAft>
+            </a:pPr>
+            <a:r>
+              <a:rPr sz="900" b="1">
+                <a:solidFill>
+                  <a:srgbClr val="F43F5E"/>
+                </a:solidFill>
+                <a:latin typeface="NanumGothic"/>
+                <a:ea typeface="NanumGothic"/>
+                <a:cs typeface="NanumGothic"/>
+              </a:rPr>
+              <a:t>Day 5 · 금</a:t>
+            </a:r>
+            <a:r>
+              <a:rPr sz="900" b="1">
+                <a:solidFill>
+                  <a:srgbClr val="64748B"/>
+                </a:solidFill>
+                <a:latin typeface="NanumGothic"/>
+                <a:ea typeface="NanumGothic"/>
+                <a:cs typeface="NanumGothic"/>
+              </a:rPr>
+              <a:t>   ·   12 / 21</a:t>
             </a:r>
           </a:p>
         </p:txBody>
@@ -7362,54 +7453,7 @@
       </p:sp>
       <p:sp>
         <p:nvSpPr>
-          <p:cNvPr id="8" name="TextBox 7"/>
-          <p:cNvSpPr txBox="1"/>
-          <p:nvPr/>
-        </p:nvSpPr>
-        <p:spPr>
-          <a:xfrm>
-            <a:off x="10241280" y="6419088"/>
-            <a:ext cx="1463040" cy="365760"/>
-          </a:xfrm>
-          <a:prstGeom prst="rect">
-            <a:avLst/>
-          </a:prstGeom>
-          <a:noFill/>
-        </p:spPr>
-        <p:txBody>
-          <a:bodyPr wrap="square" anchor="ctr" lIns="0" rIns="0" tIns="0" bIns="0">
-            <a:spAutoFit/>
-          </a:bodyPr>
-          <a:lstStyle/>
-          <a:p>
-            <a:pPr algn="r">
-              <a:lnSpc>
-                <a:spcPct val="100000"/>
-              </a:lnSpc>
-              <a:spcBef>
-                <a:spcPts val="0"/>
-              </a:spcBef>
-              <a:spcAft>
-                <a:spcPts val="600"/>
-              </a:spcAft>
-            </a:pPr>
-            <a:r>
-              <a:rPr sz="900" b="1">
-                <a:solidFill>
-                  <a:srgbClr val="F43F5E"/>
-                </a:solidFill>
-                <a:latin typeface="NanumGothic"/>
-                <a:ea typeface="NanumGothic"/>
-                <a:cs typeface="NanumGothic"/>
-              </a:rPr>
-              <a:t>Day 5 · 금</a:t>
-            </a:r>
-          </a:p>
-        </p:txBody>
-      </p:sp>
-      <p:sp>
-        <p:nvSpPr>
-          <p:cNvPr id="9" name="Rounded Rectangle 8"/>
+          <p:cNvPr id="8" name="Rounded Rectangle 7"/>
           <p:cNvSpPr/>
           <p:nvPr/>
         </p:nvSpPr>
@@ -7455,7 +7499,7 @@
       </p:sp>
       <p:sp>
         <p:nvSpPr>
-          <p:cNvPr id="10" name="Rectangle 9"/>
+          <p:cNvPr id="9" name="Rectangle 8"/>
           <p:cNvSpPr/>
           <p:nvPr/>
         </p:nvSpPr>
@@ -7499,7 +7543,7 @@
       </p:sp>
       <p:sp>
         <p:nvSpPr>
-          <p:cNvPr id="11" name="TextBox 10"/>
+          <p:cNvPr id="10" name="TextBox 9"/>
           <p:cNvSpPr txBox="1"/>
           <p:nvPr/>
         </p:nvSpPr>
@@ -7546,7 +7590,7 @@
       </p:sp>
       <p:sp>
         <p:nvSpPr>
-          <p:cNvPr id="12" name="TextBox 11"/>
+          <p:cNvPr id="11" name="TextBox 10"/>
           <p:cNvSpPr txBox="1"/>
           <p:nvPr/>
         </p:nvSpPr>
@@ -7593,7 +7637,7 @@
       </p:sp>
       <p:sp>
         <p:nvSpPr>
-          <p:cNvPr id="13" name="TextBox 12"/>
+          <p:cNvPr id="12" name="TextBox 11"/>
           <p:cNvSpPr txBox="1"/>
           <p:nvPr/>
         </p:nvSpPr>
@@ -7640,7 +7684,7 @@
       </p:sp>
       <p:sp>
         <p:nvSpPr>
-          <p:cNvPr id="14" name="TextBox 13"/>
+          <p:cNvPr id="13" name="TextBox 12"/>
           <p:cNvSpPr txBox="1"/>
           <p:nvPr/>
         </p:nvSpPr>
@@ -7687,7 +7731,7 @@
       </p:sp>
       <p:sp>
         <p:nvSpPr>
-          <p:cNvPr id="15" name="Rounded Rectangle 14"/>
+          <p:cNvPr id="14" name="Rounded Rectangle 13"/>
           <p:cNvSpPr/>
           <p:nvPr/>
         </p:nvSpPr>
@@ -7733,7 +7777,7 @@
       </p:sp>
       <p:sp>
         <p:nvSpPr>
-          <p:cNvPr id="16" name="Rectangle 15"/>
+          <p:cNvPr id="15" name="Rectangle 14"/>
           <p:cNvSpPr/>
           <p:nvPr/>
         </p:nvSpPr>
@@ -7777,7 +7821,7 @@
       </p:sp>
       <p:sp>
         <p:nvSpPr>
-          <p:cNvPr id="17" name="TextBox 16"/>
+          <p:cNvPr id="16" name="TextBox 15"/>
           <p:cNvSpPr txBox="1"/>
           <p:nvPr/>
         </p:nvSpPr>
@@ -7824,7 +7868,7 @@
       </p:sp>
       <p:sp>
         <p:nvSpPr>
-          <p:cNvPr id="18" name="TextBox 17"/>
+          <p:cNvPr id="17" name="TextBox 16"/>
           <p:cNvSpPr txBox="1"/>
           <p:nvPr/>
         </p:nvSpPr>
@@ -7871,7 +7915,7 @@
       </p:sp>
       <p:sp>
         <p:nvSpPr>
-          <p:cNvPr id="19" name="TextBox 18"/>
+          <p:cNvPr id="18" name="TextBox 17"/>
           <p:cNvSpPr txBox="1"/>
           <p:nvPr/>
         </p:nvSpPr>
@@ -7918,7 +7962,7 @@
       </p:sp>
       <p:sp>
         <p:nvSpPr>
-          <p:cNvPr id="20" name="TextBox 19"/>
+          <p:cNvPr id="19" name="TextBox 18"/>
           <p:cNvSpPr txBox="1"/>
           <p:nvPr/>
         </p:nvSpPr>
@@ -7965,7 +8009,7 @@
       </p:sp>
       <p:sp>
         <p:nvSpPr>
-          <p:cNvPr id="21" name="Rounded Rectangle 20"/>
+          <p:cNvPr id="20" name="Rounded Rectangle 19"/>
           <p:cNvSpPr/>
           <p:nvPr/>
         </p:nvSpPr>
@@ -8011,7 +8055,7 @@
       </p:sp>
       <p:sp>
         <p:nvSpPr>
-          <p:cNvPr id="22" name="Rectangle 21"/>
+          <p:cNvPr id="21" name="Rectangle 20"/>
           <p:cNvSpPr/>
           <p:nvPr/>
         </p:nvSpPr>
@@ -8055,7 +8099,7 @@
       </p:sp>
       <p:sp>
         <p:nvSpPr>
-          <p:cNvPr id="23" name="TextBox 22"/>
+          <p:cNvPr id="22" name="TextBox 21"/>
           <p:cNvSpPr txBox="1"/>
           <p:nvPr/>
         </p:nvSpPr>
@@ -8102,7 +8146,7 @@
       </p:sp>
       <p:sp>
         <p:nvSpPr>
-          <p:cNvPr id="24" name="TextBox 23"/>
+          <p:cNvPr id="23" name="TextBox 22"/>
           <p:cNvSpPr txBox="1"/>
           <p:nvPr/>
         </p:nvSpPr>
@@ -8149,7 +8193,7 @@
       </p:sp>
       <p:sp>
         <p:nvSpPr>
-          <p:cNvPr id="25" name="TextBox 24"/>
+          <p:cNvPr id="24" name="TextBox 23"/>
           <p:cNvSpPr txBox="1"/>
           <p:nvPr/>
         </p:nvSpPr>
@@ -8196,7 +8240,7 @@
       </p:sp>
       <p:sp>
         <p:nvSpPr>
-          <p:cNvPr id="26" name="TextBox 25"/>
+          <p:cNvPr id="25" name="TextBox 24"/>
           <p:cNvSpPr txBox="1"/>
           <p:nvPr/>
         </p:nvSpPr>
@@ -8243,7 +8287,7 @@
       </p:sp>
       <p:sp>
         <p:nvSpPr>
-          <p:cNvPr id="27" name="Rounded Rectangle 26"/>
+          <p:cNvPr id="26" name="Rounded Rectangle 25"/>
           <p:cNvSpPr/>
           <p:nvPr/>
         </p:nvSpPr>
@@ -8289,7 +8333,7 @@
       </p:sp>
       <p:sp>
         <p:nvSpPr>
-          <p:cNvPr id="28" name="Rectangle 27"/>
+          <p:cNvPr id="27" name="Rectangle 26"/>
           <p:cNvSpPr/>
           <p:nvPr/>
         </p:nvSpPr>
@@ -8333,7 +8377,7 @@
       </p:sp>
       <p:sp>
         <p:nvSpPr>
-          <p:cNvPr id="29" name="TextBox 28"/>
+          <p:cNvPr id="28" name="TextBox 27"/>
           <p:cNvSpPr txBox="1"/>
           <p:nvPr/>
         </p:nvSpPr>
@@ -8380,7 +8424,7 @@
       </p:sp>
       <p:sp>
         <p:nvSpPr>
-          <p:cNvPr id="30" name="TextBox 29"/>
+          <p:cNvPr id="29" name="TextBox 28"/>
           <p:cNvSpPr txBox="1"/>
           <p:nvPr/>
         </p:nvSpPr>
@@ -8427,7 +8471,7 @@
       </p:sp>
       <p:sp>
         <p:nvSpPr>
-          <p:cNvPr id="31" name="TextBox 30"/>
+          <p:cNvPr id="30" name="TextBox 29"/>
           <p:cNvSpPr txBox="1"/>
           <p:nvPr/>
         </p:nvSpPr>
@@ -8474,7 +8518,7 @@
       </p:sp>
       <p:sp>
         <p:nvSpPr>
-          <p:cNvPr id="32" name="Rounded Rectangle 31"/>
+          <p:cNvPr id="31" name="Rounded Rectangle 30"/>
           <p:cNvSpPr/>
           <p:nvPr/>
         </p:nvSpPr>
@@ -8520,7 +8564,7 @@
       </p:sp>
       <p:sp>
         <p:nvSpPr>
-          <p:cNvPr id="33" name="TextBox 32"/>
+          <p:cNvPr id="32" name="TextBox 31"/>
           <p:cNvSpPr txBox="1"/>
           <p:nvPr/>
         </p:nvSpPr>
@@ -8572,6 +8616,64 @@
                 <a:cs typeface="NanumGothic"/>
               </a:rPr>
               <a:t>사람이 방향을 주고, AI가 초안을 빠르게 만든다</a:t>
+            </a:r>
+          </a:p>
+        </p:txBody>
+      </p:sp>
+      <p:sp>
+        <p:nvSpPr>
+          <p:cNvPr id="33" name="TextBox 32"/>
+          <p:cNvSpPr txBox="1"/>
+          <p:nvPr/>
+        </p:nvSpPr>
+        <p:spPr>
+          <a:xfrm>
+            <a:off x="8988552" y="6419088"/>
+            <a:ext cx="2697480" cy="365760"/>
+          </a:xfrm>
+          <a:prstGeom prst="rect">
+            <a:avLst/>
+          </a:prstGeom>
+          <a:noFill/>
+        </p:spPr>
+        <p:txBody>
+          <a:bodyPr wrap="square" anchor="ctr" lIns="0" rIns="0" tIns="0" bIns="0">
+            <a:spAutoFit/>
+          </a:bodyPr>
+          <a:lstStyle/>
+          <a:p>
+            <a:pPr algn="r">
+              <a:lnSpc>
+                <a:spcPct val="100000"/>
+              </a:lnSpc>
+              <a:spcBef>
+                <a:spcPts val="0"/>
+              </a:spcBef>
+              <a:spcAft>
+                <a:spcPts val="600"/>
+              </a:spcAft>
+            </a:pPr>
+            <a:r>
+              <a:rPr sz="900" b="1">
+                <a:solidFill>
+                  <a:srgbClr val="F43F5E"/>
+                </a:solidFill>
+                <a:latin typeface="NanumGothic"/>
+                <a:ea typeface="NanumGothic"/>
+                <a:cs typeface="NanumGothic"/>
+              </a:rPr>
+              <a:t>Day 5 · 금</a:t>
+            </a:r>
+            <a:r>
+              <a:rPr sz="900" b="1">
+                <a:solidFill>
+                  <a:srgbClr val="64748B"/>
+                </a:solidFill>
+                <a:latin typeface="NanumGothic"/>
+                <a:ea typeface="NanumGothic"/>
+                <a:cs typeface="NanumGothic"/>
+              </a:rPr>
+              <a:t>   ·   13 / 21</a:t>
             </a:r>
           </a:p>
         </p:txBody>
@@ -8869,54 +8971,7 @@
       </p:sp>
       <p:sp>
         <p:nvSpPr>
-          <p:cNvPr id="8" name="TextBox 7"/>
-          <p:cNvSpPr txBox="1"/>
-          <p:nvPr/>
-        </p:nvSpPr>
-        <p:spPr>
-          <a:xfrm>
-            <a:off x="10241280" y="6419088"/>
-            <a:ext cx="1463040" cy="365760"/>
-          </a:xfrm>
-          <a:prstGeom prst="rect">
-            <a:avLst/>
-          </a:prstGeom>
-          <a:noFill/>
-        </p:spPr>
-        <p:txBody>
-          <a:bodyPr wrap="square" anchor="ctr" lIns="0" rIns="0" tIns="0" bIns="0">
-            <a:spAutoFit/>
-          </a:bodyPr>
-          <a:lstStyle/>
-          <a:p>
-            <a:pPr algn="r">
-              <a:lnSpc>
-                <a:spcPct val="100000"/>
-              </a:lnSpc>
-              <a:spcBef>
-                <a:spcPts val="0"/>
-              </a:spcBef>
-              <a:spcAft>
-                <a:spcPts val="600"/>
-              </a:spcAft>
-            </a:pPr>
-            <a:r>
-              <a:rPr sz="900" b="1">
-                <a:solidFill>
-                  <a:srgbClr val="F43F5E"/>
-                </a:solidFill>
-                <a:latin typeface="NanumGothic"/>
-                <a:ea typeface="NanumGothic"/>
-                <a:cs typeface="NanumGothic"/>
-              </a:rPr>
-              <a:t>Day 5 · 금</a:t>
-            </a:r>
-          </a:p>
-        </p:txBody>
-      </p:sp>
-      <p:sp>
-        <p:nvSpPr>
-          <p:cNvPr id="9" name="Oval 8"/>
+          <p:cNvPr id="8" name="Oval 7"/>
           <p:cNvSpPr/>
           <p:nvPr/>
         </p:nvSpPr>
@@ -8960,7 +9015,7 @@
       </p:sp>
       <p:sp>
         <p:nvSpPr>
-          <p:cNvPr id="10" name="TextBox 9"/>
+          <p:cNvPr id="9" name="TextBox 8"/>
           <p:cNvSpPr txBox="1"/>
           <p:nvPr/>
         </p:nvSpPr>
@@ -9007,7 +9062,7 @@
       </p:sp>
       <p:sp>
         <p:nvSpPr>
-          <p:cNvPr id="11" name="TextBox 10"/>
+          <p:cNvPr id="10" name="TextBox 9"/>
           <p:cNvSpPr txBox="1"/>
           <p:nvPr/>
         </p:nvSpPr>
@@ -9054,7 +9109,7 @@
       </p:sp>
       <p:sp>
         <p:nvSpPr>
-          <p:cNvPr id="12" name="Oval 11"/>
+          <p:cNvPr id="11" name="Oval 10"/>
           <p:cNvSpPr/>
           <p:nvPr/>
         </p:nvSpPr>
@@ -9098,7 +9153,7 @@
       </p:sp>
       <p:sp>
         <p:nvSpPr>
-          <p:cNvPr id="13" name="TextBox 12"/>
+          <p:cNvPr id="12" name="TextBox 11"/>
           <p:cNvSpPr txBox="1"/>
           <p:nvPr/>
         </p:nvSpPr>
@@ -9145,7 +9200,7 @@
       </p:sp>
       <p:sp>
         <p:nvSpPr>
-          <p:cNvPr id="14" name="TextBox 13"/>
+          <p:cNvPr id="13" name="TextBox 12"/>
           <p:cNvSpPr txBox="1"/>
           <p:nvPr/>
         </p:nvSpPr>
@@ -9192,7 +9247,7 @@
       </p:sp>
       <p:sp>
         <p:nvSpPr>
-          <p:cNvPr id="15" name="Oval 14"/>
+          <p:cNvPr id="14" name="Oval 13"/>
           <p:cNvSpPr/>
           <p:nvPr/>
         </p:nvSpPr>
@@ -9236,7 +9291,7 @@
       </p:sp>
       <p:sp>
         <p:nvSpPr>
-          <p:cNvPr id="16" name="TextBox 15"/>
+          <p:cNvPr id="15" name="TextBox 14"/>
           <p:cNvSpPr txBox="1"/>
           <p:nvPr/>
         </p:nvSpPr>
@@ -9283,7 +9338,7 @@
       </p:sp>
       <p:sp>
         <p:nvSpPr>
-          <p:cNvPr id="17" name="TextBox 16"/>
+          <p:cNvPr id="16" name="TextBox 15"/>
           <p:cNvSpPr txBox="1"/>
           <p:nvPr/>
         </p:nvSpPr>
@@ -9324,6 +9379,64 @@
                 <a:cs typeface="NanumGothic"/>
               </a:rPr>
               <a:t>결과·근거를 함께 전달</a:t>
+            </a:r>
+          </a:p>
+        </p:txBody>
+      </p:sp>
+      <p:sp>
+        <p:nvSpPr>
+          <p:cNvPr id="17" name="TextBox 16"/>
+          <p:cNvSpPr txBox="1"/>
+          <p:nvPr/>
+        </p:nvSpPr>
+        <p:spPr>
+          <a:xfrm>
+            <a:off x="8988552" y="6419088"/>
+            <a:ext cx="2697480" cy="365760"/>
+          </a:xfrm>
+          <a:prstGeom prst="rect">
+            <a:avLst/>
+          </a:prstGeom>
+          <a:noFill/>
+        </p:spPr>
+        <p:txBody>
+          <a:bodyPr wrap="square" anchor="ctr" lIns="0" rIns="0" tIns="0" bIns="0">
+            <a:spAutoFit/>
+          </a:bodyPr>
+          <a:lstStyle/>
+          <a:p>
+            <a:pPr algn="r">
+              <a:lnSpc>
+                <a:spcPct val="100000"/>
+              </a:lnSpc>
+              <a:spcBef>
+                <a:spcPts val="0"/>
+              </a:spcBef>
+              <a:spcAft>
+                <a:spcPts val="600"/>
+              </a:spcAft>
+            </a:pPr>
+            <a:r>
+              <a:rPr sz="900" b="1">
+                <a:solidFill>
+                  <a:srgbClr val="F43F5E"/>
+                </a:solidFill>
+                <a:latin typeface="NanumGothic"/>
+                <a:ea typeface="NanumGothic"/>
+                <a:cs typeface="NanumGothic"/>
+              </a:rPr>
+              <a:t>Day 5 · 금</a:t>
+            </a:r>
+            <a:r>
+              <a:rPr sz="900" b="1">
+                <a:solidFill>
+                  <a:srgbClr val="64748B"/>
+                </a:solidFill>
+                <a:latin typeface="NanumGothic"/>
+                <a:ea typeface="NanumGothic"/>
+                <a:cs typeface="NanumGothic"/>
+              </a:rPr>
+              <a:t>   ·   14 / 21</a:t>
             </a:r>
           </a:p>
         </p:txBody>
@@ -9621,54 +9734,7 @@
       </p:sp>
       <p:sp>
         <p:nvSpPr>
-          <p:cNvPr id="8" name="TextBox 7"/>
-          <p:cNvSpPr txBox="1"/>
-          <p:nvPr/>
-        </p:nvSpPr>
-        <p:spPr>
-          <a:xfrm>
-            <a:off x="10241280" y="6419088"/>
-            <a:ext cx="1463040" cy="365760"/>
-          </a:xfrm>
-          <a:prstGeom prst="rect">
-            <a:avLst/>
-          </a:prstGeom>
-          <a:noFill/>
-        </p:spPr>
-        <p:txBody>
-          <a:bodyPr wrap="square" anchor="ctr" lIns="0" rIns="0" tIns="0" bIns="0">
-            <a:spAutoFit/>
-          </a:bodyPr>
-          <a:lstStyle/>
-          <a:p>
-            <a:pPr algn="r">
-              <a:lnSpc>
-                <a:spcPct val="100000"/>
-              </a:lnSpc>
-              <a:spcBef>
-                <a:spcPts val="0"/>
-              </a:spcBef>
-              <a:spcAft>
-                <a:spcPts val="600"/>
-              </a:spcAft>
-            </a:pPr>
-            <a:r>
-              <a:rPr sz="900" b="1">
-                <a:solidFill>
-                  <a:srgbClr val="F43F5E"/>
-                </a:solidFill>
-                <a:latin typeface="NanumGothic"/>
-                <a:ea typeface="NanumGothic"/>
-                <a:cs typeface="NanumGothic"/>
-              </a:rPr>
-              <a:t>Day 5 · 금</a:t>
-            </a:r>
-          </a:p>
-        </p:txBody>
-      </p:sp>
-      <p:sp>
-        <p:nvSpPr>
-          <p:cNvPr id="9" name="Oval 8"/>
+          <p:cNvPr id="8" name="Oval 7"/>
           <p:cNvSpPr/>
           <p:nvPr/>
         </p:nvSpPr>
@@ -9712,7 +9778,7 @@
       </p:sp>
       <p:sp>
         <p:nvSpPr>
-          <p:cNvPr id="10" name="TextBox 9"/>
+          <p:cNvPr id="9" name="TextBox 8"/>
           <p:cNvSpPr txBox="1"/>
           <p:nvPr/>
         </p:nvSpPr>
@@ -9759,7 +9825,7 @@
       </p:sp>
       <p:sp>
         <p:nvSpPr>
-          <p:cNvPr id="11" name="TextBox 10"/>
+          <p:cNvPr id="10" name="TextBox 9"/>
           <p:cNvSpPr txBox="1"/>
           <p:nvPr/>
         </p:nvSpPr>
@@ -9806,7 +9872,7 @@
       </p:sp>
       <p:sp>
         <p:nvSpPr>
-          <p:cNvPr id="12" name="Oval 11"/>
+          <p:cNvPr id="11" name="Oval 10"/>
           <p:cNvSpPr/>
           <p:nvPr/>
         </p:nvSpPr>
@@ -9850,7 +9916,7 @@
       </p:sp>
       <p:sp>
         <p:nvSpPr>
-          <p:cNvPr id="13" name="TextBox 12"/>
+          <p:cNvPr id="12" name="TextBox 11"/>
           <p:cNvSpPr txBox="1"/>
           <p:nvPr/>
         </p:nvSpPr>
@@ -9897,7 +9963,7 @@
       </p:sp>
       <p:sp>
         <p:nvSpPr>
-          <p:cNvPr id="14" name="TextBox 13"/>
+          <p:cNvPr id="13" name="TextBox 12"/>
           <p:cNvSpPr txBox="1"/>
           <p:nvPr/>
         </p:nvSpPr>
@@ -9944,7 +10010,7 @@
       </p:sp>
       <p:sp>
         <p:nvSpPr>
-          <p:cNvPr id="15" name="Oval 14"/>
+          <p:cNvPr id="14" name="Oval 13"/>
           <p:cNvSpPr/>
           <p:nvPr/>
         </p:nvSpPr>
@@ -9988,7 +10054,7 @@
       </p:sp>
       <p:sp>
         <p:nvSpPr>
-          <p:cNvPr id="16" name="TextBox 15"/>
+          <p:cNvPr id="15" name="TextBox 14"/>
           <p:cNvSpPr txBox="1"/>
           <p:nvPr/>
         </p:nvSpPr>
@@ -10035,7 +10101,7 @@
       </p:sp>
       <p:sp>
         <p:nvSpPr>
-          <p:cNvPr id="17" name="TextBox 16"/>
+          <p:cNvPr id="16" name="TextBox 15"/>
           <p:cNvSpPr txBox="1"/>
           <p:nvPr/>
         </p:nvSpPr>
@@ -10082,7 +10148,7 @@
       </p:sp>
       <p:sp>
         <p:nvSpPr>
-          <p:cNvPr id="18" name="Rounded Rectangle 17"/>
+          <p:cNvPr id="17" name="Rounded Rectangle 16"/>
           <p:cNvSpPr/>
           <p:nvPr/>
         </p:nvSpPr>
@@ -10128,7 +10194,7 @@
       </p:sp>
       <p:sp>
         <p:nvSpPr>
-          <p:cNvPr id="19" name="TextBox 18"/>
+          <p:cNvPr id="18" name="TextBox 17"/>
           <p:cNvSpPr txBox="1"/>
           <p:nvPr/>
         </p:nvSpPr>
@@ -10180,6 +10246,64 @@
                 <a:cs typeface="NanumGothic"/>
               </a:rPr>
               <a:t>AI 초안 ≠ 최종본 — 반드시 검토</a:t>
+            </a:r>
+          </a:p>
+        </p:txBody>
+      </p:sp>
+      <p:sp>
+        <p:nvSpPr>
+          <p:cNvPr id="19" name="TextBox 18"/>
+          <p:cNvSpPr txBox="1"/>
+          <p:nvPr/>
+        </p:nvSpPr>
+        <p:spPr>
+          <a:xfrm>
+            <a:off x="8988552" y="6419088"/>
+            <a:ext cx="2697480" cy="365760"/>
+          </a:xfrm>
+          <a:prstGeom prst="rect">
+            <a:avLst/>
+          </a:prstGeom>
+          <a:noFill/>
+        </p:spPr>
+        <p:txBody>
+          <a:bodyPr wrap="square" anchor="ctr" lIns="0" rIns="0" tIns="0" bIns="0">
+            <a:spAutoFit/>
+          </a:bodyPr>
+          <a:lstStyle/>
+          <a:p>
+            <a:pPr algn="r">
+              <a:lnSpc>
+                <a:spcPct val="100000"/>
+              </a:lnSpc>
+              <a:spcBef>
+                <a:spcPts val="0"/>
+              </a:spcBef>
+              <a:spcAft>
+                <a:spcPts val="600"/>
+              </a:spcAft>
+            </a:pPr>
+            <a:r>
+              <a:rPr sz="900" b="1">
+                <a:solidFill>
+                  <a:srgbClr val="F43F5E"/>
+                </a:solidFill>
+                <a:latin typeface="NanumGothic"/>
+                <a:ea typeface="NanumGothic"/>
+                <a:cs typeface="NanumGothic"/>
+              </a:rPr>
+              <a:t>Day 5 · 금</a:t>
+            </a:r>
+            <a:r>
+              <a:rPr sz="900" b="1">
+                <a:solidFill>
+                  <a:srgbClr val="64748B"/>
+                </a:solidFill>
+                <a:latin typeface="NanumGothic"/>
+                <a:ea typeface="NanumGothic"/>
+                <a:cs typeface="NanumGothic"/>
+              </a:rPr>
+              <a:t>   ·   15 / 21</a:t>
             </a:r>
           </a:p>
         </p:txBody>
@@ -10477,54 +10601,7 @@
       </p:sp>
       <p:sp>
         <p:nvSpPr>
-          <p:cNvPr id="8" name="TextBox 7"/>
-          <p:cNvSpPr txBox="1"/>
-          <p:nvPr/>
-        </p:nvSpPr>
-        <p:spPr>
-          <a:xfrm>
-            <a:off x="10241280" y="6419088"/>
-            <a:ext cx="1463040" cy="365760"/>
-          </a:xfrm>
-          <a:prstGeom prst="rect">
-            <a:avLst/>
-          </a:prstGeom>
-          <a:noFill/>
-        </p:spPr>
-        <p:txBody>
-          <a:bodyPr wrap="square" anchor="ctr" lIns="0" rIns="0" tIns="0" bIns="0">
-            <a:spAutoFit/>
-          </a:bodyPr>
-          <a:lstStyle/>
-          <a:p>
-            <a:pPr algn="r">
-              <a:lnSpc>
-                <a:spcPct val="100000"/>
-              </a:lnSpc>
-              <a:spcBef>
-                <a:spcPts val="0"/>
-              </a:spcBef>
-              <a:spcAft>
-                <a:spcPts val="600"/>
-              </a:spcAft>
-            </a:pPr>
-            <a:r>
-              <a:rPr sz="900" b="1">
-                <a:solidFill>
-                  <a:srgbClr val="F43F5E"/>
-                </a:solidFill>
-                <a:latin typeface="NanumGothic"/>
-                <a:ea typeface="NanumGothic"/>
-                <a:cs typeface="NanumGothic"/>
-              </a:rPr>
-              <a:t>Day 5 · 금</a:t>
-            </a:r>
-          </a:p>
-        </p:txBody>
-      </p:sp>
-      <p:sp>
-        <p:nvSpPr>
-          <p:cNvPr id="9" name="Rounded Rectangle 8"/>
+          <p:cNvPr id="8" name="Rounded Rectangle 7"/>
           <p:cNvSpPr/>
           <p:nvPr/>
         </p:nvSpPr>
@@ -10570,7 +10647,7 @@
       </p:sp>
       <p:sp>
         <p:nvSpPr>
-          <p:cNvPr id="10" name="TextBox 9"/>
+          <p:cNvPr id="9" name="TextBox 8"/>
           <p:cNvSpPr txBox="1"/>
           <p:nvPr/>
         </p:nvSpPr>
@@ -10617,7 +10694,7 @@
       </p:sp>
       <p:sp>
         <p:nvSpPr>
-          <p:cNvPr id="11" name="Oval 10"/>
+          <p:cNvPr id="10" name="Oval 9"/>
           <p:cNvSpPr/>
           <p:nvPr/>
         </p:nvSpPr>
@@ -10661,7 +10738,7 @@
       </p:sp>
       <p:sp>
         <p:nvSpPr>
-          <p:cNvPr id="12" name="TextBox 11"/>
+          <p:cNvPr id="11" name="TextBox 10"/>
           <p:cNvSpPr txBox="1"/>
           <p:nvPr/>
         </p:nvSpPr>
@@ -10708,7 +10785,7 @@
       </p:sp>
       <p:sp>
         <p:nvSpPr>
-          <p:cNvPr id="13" name="TextBox 12"/>
+          <p:cNvPr id="12" name="TextBox 11"/>
           <p:cNvSpPr txBox="1"/>
           <p:nvPr/>
         </p:nvSpPr>
@@ -10755,7 +10832,7 @@
       </p:sp>
       <p:sp>
         <p:nvSpPr>
-          <p:cNvPr id="14" name="Oval 13"/>
+          <p:cNvPr id="13" name="Oval 12"/>
           <p:cNvSpPr/>
           <p:nvPr/>
         </p:nvSpPr>
@@ -10799,7 +10876,7 @@
       </p:sp>
       <p:sp>
         <p:nvSpPr>
-          <p:cNvPr id="15" name="TextBox 14"/>
+          <p:cNvPr id="14" name="TextBox 13"/>
           <p:cNvSpPr txBox="1"/>
           <p:nvPr/>
         </p:nvSpPr>
@@ -10846,7 +10923,7 @@
       </p:sp>
       <p:sp>
         <p:nvSpPr>
-          <p:cNvPr id="16" name="TextBox 15"/>
+          <p:cNvPr id="15" name="TextBox 14"/>
           <p:cNvSpPr txBox="1"/>
           <p:nvPr/>
         </p:nvSpPr>
@@ -10893,7 +10970,7 @@
       </p:sp>
       <p:sp>
         <p:nvSpPr>
-          <p:cNvPr id="17" name="Oval 16"/>
+          <p:cNvPr id="16" name="Oval 15"/>
           <p:cNvSpPr/>
           <p:nvPr/>
         </p:nvSpPr>
@@ -10937,7 +11014,7 @@
       </p:sp>
       <p:sp>
         <p:nvSpPr>
-          <p:cNvPr id="18" name="TextBox 17"/>
+          <p:cNvPr id="17" name="TextBox 16"/>
           <p:cNvSpPr txBox="1"/>
           <p:nvPr/>
         </p:nvSpPr>
@@ -10984,7 +11061,7 @@
       </p:sp>
       <p:sp>
         <p:nvSpPr>
-          <p:cNvPr id="19" name="TextBox 18"/>
+          <p:cNvPr id="18" name="TextBox 17"/>
           <p:cNvSpPr txBox="1"/>
           <p:nvPr/>
         </p:nvSpPr>
@@ -11031,7 +11108,7 @@
       </p:sp>
       <p:sp>
         <p:nvSpPr>
-          <p:cNvPr id="20" name="Oval 19"/>
+          <p:cNvPr id="19" name="Oval 18"/>
           <p:cNvSpPr/>
           <p:nvPr/>
         </p:nvSpPr>
@@ -11075,7 +11152,7 @@
       </p:sp>
       <p:sp>
         <p:nvSpPr>
-          <p:cNvPr id="21" name="TextBox 20"/>
+          <p:cNvPr id="20" name="TextBox 19"/>
           <p:cNvSpPr txBox="1"/>
           <p:nvPr/>
         </p:nvSpPr>
@@ -11122,7 +11199,7 @@
       </p:sp>
       <p:sp>
         <p:nvSpPr>
-          <p:cNvPr id="22" name="TextBox 21"/>
+          <p:cNvPr id="21" name="TextBox 20"/>
           <p:cNvSpPr txBox="1"/>
           <p:nvPr/>
         </p:nvSpPr>
@@ -11169,7 +11246,7 @@
       </p:sp>
       <p:sp>
         <p:nvSpPr>
-          <p:cNvPr id="23" name="Rounded Rectangle 22"/>
+          <p:cNvPr id="22" name="Rounded Rectangle 21"/>
           <p:cNvSpPr/>
           <p:nvPr/>
         </p:nvSpPr>
@@ -11213,7 +11290,7 @@
       </p:sp>
       <p:sp>
         <p:nvSpPr>
-          <p:cNvPr id="24" name="TextBox 23"/>
+          <p:cNvPr id="23" name="TextBox 22"/>
           <p:cNvSpPr txBox="1"/>
           <p:nvPr/>
         </p:nvSpPr>
@@ -11260,7 +11337,7 @@
       </p:sp>
       <p:sp>
         <p:nvSpPr>
-          <p:cNvPr id="25" name="TextBox 24"/>
+          <p:cNvPr id="24" name="TextBox 23"/>
           <p:cNvSpPr txBox="1"/>
           <p:nvPr/>
         </p:nvSpPr>
@@ -11302,6 +11379,64 @@
               </a:rPr>
               <a:t>발표 슬라이드 + 가설 제안서 초안
 제안서 양식: examples/research-agent/output/report-template.md</a:t>
+            </a:r>
+          </a:p>
+        </p:txBody>
+      </p:sp>
+      <p:sp>
+        <p:nvSpPr>
+          <p:cNvPr id="25" name="TextBox 24"/>
+          <p:cNvSpPr txBox="1"/>
+          <p:nvPr/>
+        </p:nvSpPr>
+        <p:spPr>
+          <a:xfrm>
+            <a:off x="8988552" y="6419088"/>
+            <a:ext cx="2697480" cy="365760"/>
+          </a:xfrm>
+          <a:prstGeom prst="rect">
+            <a:avLst/>
+          </a:prstGeom>
+          <a:noFill/>
+        </p:spPr>
+        <p:txBody>
+          <a:bodyPr wrap="square" anchor="ctr" lIns="0" rIns="0" tIns="0" bIns="0">
+            <a:spAutoFit/>
+          </a:bodyPr>
+          <a:lstStyle/>
+          <a:p>
+            <a:pPr algn="r">
+              <a:lnSpc>
+                <a:spcPct val="100000"/>
+              </a:lnSpc>
+              <a:spcBef>
+                <a:spcPts val="0"/>
+              </a:spcBef>
+              <a:spcAft>
+                <a:spcPts val="600"/>
+              </a:spcAft>
+            </a:pPr>
+            <a:r>
+              <a:rPr sz="900" b="1">
+                <a:solidFill>
+                  <a:srgbClr val="F43F5E"/>
+                </a:solidFill>
+                <a:latin typeface="NanumGothic"/>
+                <a:ea typeface="NanumGothic"/>
+                <a:cs typeface="NanumGothic"/>
+              </a:rPr>
+              <a:t>Day 5 · 금</a:t>
+            </a:r>
+            <a:r>
+              <a:rPr sz="900" b="1">
+                <a:solidFill>
+                  <a:srgbClr val="64748B"/>
+                </a:solidFill>
+                <a:latin typeface="NanumGothic"/>
+                <a:ea typeface="NanumGothic"/>
+                <a:cs typeface="NanumGothic"/>
+              </a:rPr>
+              <a:t>   ·   16 / 21</a:t>
             </a:r>
           </a:p>
         </p:txBody>
@@ -11608,6 +11743,64 @@
           </a:p>
         </p:txBody>
       </p:sp>
+      <p:sp>
+        <p:nvSpPr>
+          <p:cNvPr id="8" name="TextBox 7"/>
+          <p:cNvSpPr txBox="1"/>
+          <p:nvPr/>
+        </p:nvSpPr>
+        <p:spPr>
+          <a:xfrm>
+            <a:off x="8988552" y="6419088"/>
+            <a:ext cx="2697480" cy="365760"/>
+          </a:xfrm>
+          <a:prstGeom prst="rect">
+            <a:avLst/>
+          </a:prstGeom>
+          <a:noFill/>
+        </p:spPr>
+        <p:txBody>
+          <a:bodyPr wrap="square" anchor="ctr" lIns="0" rIns="0" tIns="0" bIns="0">
+            <a:spAutoFit/>
+          </a:bodyPr>
+          <a:lstStyle/>
+          <a:p>
+            <a:pPr algn="r">
+              <a:lnSpc>
+                <a:spcPct val="100000"/>
+              </a:lnSpc>
+              <a:spcBef>
+                <a:spcPts val="0"/>
+              </a:spcBef>
+              <a:spcAft>
+                <a:spcPts val="600"/>
+              </a:spcAft>
+            </a:pPr>
+            <a:r>
+              <a:rPr sz="900" b="1">
+                <a:solidFill>
+                  <a:srgbClr val="F43F5E"/>
+                </a:solidFill>
+                <a:latin typeface="NanumGothic"/>
+                <a:ea typeface="NanumGothic"/>
+                <a:cs typeface="NanumGothic"/>
+              </a:rPr>
+              <a:t>Day 5 · 금</a:t>
+            </a:r>
+            <a:r>
+              <a:rPr sz="900" b="1">
+                <a:solidFill>
+                  <a:srgbClr val="CBD5E1"/>
+                </a:solidFill>
+                <a:latin typeface="NanumGothic"/>
+                <a:ea typeface="NanumGothic"/>
+                <a:cs typeface="NanumGothic"/>
+              </a:rPr>
+              <a:t>   ·   17 / 21</a:t>
+            </a:r>
+          </a:p>
+        </p:txBody>
+      </p:sp>
     </p:spTree>
   </p:cSld>
   <p:clrMapOvr>
@@ -11901,54 +12094,7 @@
       </p:sp>
       <p:sp>
         <p:nvSpPr>
-          <p:cNvPr id="8" name="TextBox 7"/>
-          <p:cNvSpPr txBox="1"/>
-          <p:nvPr/>
-        </p:nvSpPr>
-        <p:spPr>
-          <a:xfrm>
-            <a:off x="10241280" y="6419088"/>
-            <a:ext cx="1463040" cy="365760"/>
-          </a:xfrm>
-          <a:prstGeom prst="rect">
-            <a:avLst/>
-          </a:prstGeom>
-          <a:noFill/>
-        </p:spPr>
-        <p:txBody>
-          <a:bodyPr wrap="square" anchor="ctr" lIns="0" rIns="0" tIns="0" bIns="0">
-            <a:spAutoFit/>
-          </a:bodyPr>
-          <a:lstStyle/>
-          <a:p>
-            <a:pPr algn="r">
-              <a:lnSpc>
-                <a:spcPct val="100000"/>
-              </a:lnSpc>
-              <a:spcBef>
-                <a:spcPts val="0"/>
-              </a:spcBef>
-              <a:spcAft>
-                <a:spcPts val="600"/>
-              </a:spcAft>
-            </a:pPr>
-            <a:r>
-              <a:rPr sz="900" b="1">
-                <a:solidFill>
-                  <a:srgbClr val="F43F5E"/>
-                </a:solidFill>
-                <a:latin typeface="NanumGothic"/>
-                <a:ea typeface="NanumGothic"/>
-                <a:cs typeface="NanumGothic"/>
-              </a:rPr>
-              <a:t>Day 5 · 금</a:t>
-            </a:r>
-          </a:p>
-        </p:txBody>
-      </p:sp>
-      <p:sp>
-        <p:nvSpPr>
-          <p:cNvPr id="9" name="Rounded Rectangle 8"/>
+          <p:cNvPr id="8" name="Rounded Rectangle 7"/>
           <p:cNvSpPr/>
           <p:nvPr/>
         </p:nvSpPr>
@@ -11994,7 +12140,7 @@
       </p:sp>
       <p:sp>
         <p:nvSpPr>
-          <p:cNvPr id="10" name="TextBox 9"/>
+          <p:cNvPr id="9" name="TextBox 8"/>
           <p:cNvSpPr txBox="1"/>
           <p:nvPr/>
         </p:nvSpPr>
@@ -12041,7 +12187,7 @@
       </p:sp>
       <p:sp>
         <p:nvSpPr>
-          <p:cNvPr id="11" name="TextBox 10"/>
+          <p:cNvPr id="10" name="TextBox 9"/>
           <p:cNvSpPr txBox="1"/>
           <p:nvPr/>
         </p:nvSpPr>
@@ -12088,7 +12234,7 @@
       </p:sp>
       <p:sp>
         <p:nvSpPr>
-          <p:cNvPr id="12" name="Rounded Rectangle 11"/>
+          <p:cNvPr id="11" name="Rounded Rectangle 10"/>
           <p:cNvSpPr/>
           <p:nvPr/>
         </p:nvSpPr>
@@ -12134,7 +12280,7 @@
       </p:sp>
       <p:sp>
         <p:nvSpPr>
-          <p:cNvPr id="13" name="Oval 12"/>
+          <p:cNvPr id="12" name="Oval 11"/>
           <p:cNvSpPr/>
           <p:nvPr/>
         </p:nvSpPr>
@@ -12178,7 +12324,7 @@
       </p:sp>
       <p:sp>
         <p:nvSpPr>
-          <p:cNvPr id="14" name="TextBox 13"/>
+          <p:cNvPr id="13" name="TextBox 12"/>
           <p:cNvSpPr txBox="1"/>
           <p:nvPr/>
         </p:nvSpPr>
@@ -12225,7 +12371,7 @@
       </p:sp>
       <p:sp>
         <p:nvSpPr>
-          <p:cNvPr id="15" name="TextBox 14"/>
+          <p:cNvPr id="14" name="TextBox 13"/>
           <p:cNvSpPr txBox="1"/>
           <p:nvPr/>
         </p:nvSpPr>
@@ -12272,7 +12418,7 @@
       </p:sp>
       <p:sp>
         <p:nvSpPr>
-          <p:cNvPr id="16" name="Rounded Rectangle 15"/>
+          <p:cNvPr id="15" name="Rounded Rectangle 14"/>
           <p:cNvSpPr/>
           <p:nvPr/>
         </p:nvSpPr>
@@ -12318,7 +12464,7 @@
       </p:sp>
       <p:sp>
         <p:nvSpPr>
-          <p:cNvPr id="17" name="Oval 16"/>
+          <p:cNvPr id="16" name="Oval 15"/>
           <p:cNvSpPr/>
           <p:nvPr/>
         </p:nvSpPr>
@@ -12362,7 +12508,7 @@
       </p:sp>
       <p:sp>
         <p:nvSpPr>
-          <p:cNvPr id="18" name="TextBox 17"/>
+          <p:cNvPr id="17" name="TextBox 16"/>
           <p:cNvSpPr txBox="1"/>
           <p:nvPr/>
         </p:nvSpPr>
@@ -12409,7 +12555,7 @@
       </p:sp>
       <p:sp>
         <p:nvSpPr>
-          <p:cNvPr id="19" name="TextBox 18"/>
+          <p:cNvPr id="18" name="TextBox 17"/>
           <p:cNvSpPr txBox="1"/>
           <p:nvPr/>
         </p:nvSpPr>
@@ -12450,6 +12596,64 @@
                 <a:cs typeface="NanumGothic"/>
               </a:rPr>
               <a:t>과정 회고 및 향후 계획</a:t>
+            </a:r>
+          </a:p>
+        </p:txBody>
+      </p:sp>
+      <p:sp>
+        <p:nvSpPr>
+          <p:cNvPr id="19" name="TextBox 18"/>
+          <p:cNvSpPr txBox="1"/>
+          <p:nvPr/>
+        </p:nvSpPr>
+        <p:spPr>
+          <a:xfrm>
+            <a:off x="8988552" y="6419088"/>
+            <a:ext cx="2697480" cy="365760"/>
+          </a:xfrm>
+          <a:prstGeom prst="rect">
+            <a:avLst/>
+          </a:prstGeom>
+          <a:noFill/>
+        </p:spPr>
+        <p:txBody>
+          <a:bodyPr wrap="square" anchor="ctr" lIns="0" rIns="0" tIns="0" bIns="0">
+            <a:spAutoFit/>
+          </a:bodyPr>
+          <a:lstStyle/>
+          <a:p>
+            <a:pPr algn="r">
+              <a:lnSpc>
+                <a:spcPct val="100000"/>
+              </a:lnSpc>
+              <a:spcBef>
+                <a:spcPts val="0"/>
+              </a:spcBef>
+              <a:spcAft>
+                <a:spcPts val="600"/>
+              </a:spcAft>
+            </a:pPr>
+            <a:r>
+              <a:rPr sz="900" b="1">
+                <a:solidFill>
+                  <a:srgbClr val="F43F5E"/>
+                </a:solidFill>
+                <a:latin typeface="NanumGothic"/>
+                <a:ea typeface="NanumGothic"/>
+                <a:cs typeface="NanumGothic"/>
+              </a:rPr>
+              <a:t>Day 5 · 금</a:t>
+            </a:r>
+            <a:r>
+              <a:rPr sz="900" b="1">
+                <a:solidFill>
+                  <a:srgbClr val="64748B"/>
+                </a:solidFill>
+                <a:latin typeface="NanumGothic"/>
+                <a:ea typeface="NanumGothic"/>
+                <a:cs typeface="NanumGothic"/>
+              </a:rPr>
+              <a:t>   ·   18 / 21</a:t>
             </a:r>
           </a:p>
         </p:txBody>
@@ -12747,54 +12951,7 @@
       </p:sp>
       <p:sp>
         <p:nvSpPr>
-          <p:cNvPr id="8" name="TextBox 7"/>
-          <p:cNvSpPr txBox="1"/>
-          <p:nvPr/>
-        </p:nvSpPr>
-        <p:spPr>
-          <a:xfrm>
-            <a:off x="10241280" y="6419088"/>
-            <a:ext cx="1463040" cy="365760"/>
-          </a:xfrm>
-          <a:prstGeom prst="rect">
-            <a:avLst/>
-          </a:prstGeom>
-          <a:noFill/>
-        </p:spPr>
-        <p:txBody>
-          <a:bodyPr wrap="square" anchor="ctr" lIns="0" rIns="0" tIns="0" bIns="0">
-            <a:spAutoFit/>
-          </a:bodyPr>
-          <a:lstStyle/>
-          <a:p>
-            <a:pPr algn="r">
-              <a:lnSpc>
-                <a:spcPct val="100000"/>
-              </a:lnSpc>
-              <a:spcBef>
-                <a:spcPts val="0"/>
-              </a:spcBef>
-              <a:spcAft>
-                <a:spcPts val="600"/>
-              </a:spcAft>
-            </a:pPr>
-            <a:r>
-              <a:rPr sz="900" b="1">
-                <a:solidFill>
-                  <a:srgbClr val="F43F5E"/>
-                </a:solidFill>
-                <a:latin typeface="NanumGothic"/>
-                <a:ea typeface="NanumGothic"/>
-                <a:cs typeface="NanumGothic"/>
-              </a:rPr>
-              <a:t>Day 5 · 금</a:t>
-            </a:r>
-          </a:p>
-        </p:txBody>
-      </p:sp>
-      <p:sp>
-        <p:nvSpPr>
-          <p:cNvPr id="9" name="Oval 8"/>
+          <p:cNvPr id="8" name="Oval 7"/>
           <p:cNvSpPr/>
           <p:nvPr/>
         </p:nvSpPr>
@@ -12838,7 +12995,7 @@
       </p:sp>
       <p:sp>
         <p:nvSpPr>
-          <p:cNvPr id="10" name="TextBox 9"/>
+          <p:cNvPr id="9" name="TextBox 8"/>
           <p:cNvSpPr txBox="1"/>
           <p:nvPr/>
         </p:nvSpPr>
@@ -12885,7 +13042,7 @@
       </p:sp>
       <p:sp>
         <p:nvSpPr>
-          <p:cNvPr id="11" name="TextBox 10"/>
+          <p:cNvPr id="10" name="TextBox 9"/>
           <p:cNvSpPr txBox="1"/>
           <p:nvPr/>
         </p:nvSpPr>
@@ -12932,7 +13089,7 @@
       </p:sp>
       <p:sp>
         <p:nvSpPr>
-          <p:cNvPr id="12" name="Oval 11"/>
+          <p:cNvPr id="11" name="Oval 10"/>
           <p:cNvSpPr/>
           <p:nvPr/>
         </p:nvSpPr>
@@ -12976,7 +13133,7 @@
       </p:sp>
       <p:sp>
         <p:nvSpPr>
-          <p:cNvPr id="13" name="TextBox 12"/>
+          <p:cNvPr id="12" name="TextBox 11"/>
           <p:cNvSpPr txBox="1"/>
           <p:nvPr/>
         </p:nvSpPr>
@@ -13023,7 +13180,7 @@
       </p:sp>
       <p:sp>
         <p:nvSpPr>
-          <p:cNvPr id="14" name="TextBox 13"/>
+          <p:cNvPr id="13" name="TextBox 12"/>
           <p:cNvSpPr txBox="1"/>
           <p:nvPr/>
         </p:nvSpPr>
@@ -13070,7 +13227,7 @@
       </p:sp>
       <p:sp>
         <p:nvSpPr>
-          <p:cNvPr id="15" name="Oval 14"/>
+          <p:cNvPr id="14" name="Oval 13"/>
           <p:cNvSpPr/>
           <p:nvPr/>
         </p:nvSpPr>
@@ -13114,7 +13271,7 @@
       </p:sp>
       <p:sp>
         <p:nvSpPr>
-          <p:cNvPr id="16" name="TextBox 15"/>
+          <p:cNvPr id="15" name="TextBox 14"/>
           <p:cNvSpPr txBox="1"/>
           <p:nvPr/>
         </p:nvSpPr>
@@ -13161,7 +13318,7 @@
       </p:sp>
       <p:sp>
         <p:nvSpPr>
-          <p:cNvPr id="17" name="TextBox 16"/>
+          <p:cNvPr id="16" name="TextBox 15"/>
           <p:cNvSpPr txBox="1"/>
           <p:nvPr/>
         </p:nvSpPr>
@@ -13202,6 +13359,64 @@
                 <a:cs typeface="NanumGothic"/>
               </a:rPr>
               <a:t>잘한 점 · 배운 점 · 다음 단계</a:t>
+            </a:r>
+          </a:p>
+        </p:txBody>
+      </p:sp>
+      <p:sp>
+        <p:nvSpPr>
+          <p:cNvPr id="17" name="TextBox 16"/>
+          <p:cNvSpPr txBox="1"/>
+          <p:nvPr/>
+        </p:nvSpPr>
+        <p:spPr>
+          <a:xfrm>
+            <a:off x="8988552" y="6419088"/>
+            <a:ext cx="2697480" cy="365760"/>
+          </a:xfrm>
+          <a:prstGeom prst="rect">
+            <a:avLst/>
+          </a:prstGeom>
+          <a:noFill/>
+        </p:spPr>
+        <p:txBody>
+          <a:bodyPr wrap="square" anchor="ctr" lIns="0" rIns="0" tIns="0" bIns="0">
+            <a:spAutoFit/>
+          </a:bodyPr>
+          <a:lstStyle/>
+          <a:p>
+            <a:pPr algn="r">
+              <a:lnSpc>
+                <a:spcPct val="100000"/>
+              </a:lnSpc>
+              <a:spcBef>
+                <a:spcPts val="0"/>
+              </a:spcBef>
+              <a:spcAft>
+                <a:spcPts val="600"/>
+              </a:spcAft>
+            </a:pPr>
+            <a:r>
+              <a:rPr sz="900" b="1">
+                <a:solidFill>
+                  <a:srgbClr val="F43F5E"/>
+                </a:solidFill>
+                <a:latin typeface="NanumGothic"/>
+                <a:ea typeface="NanumGothic"/>
+                <a:cs typeface="NanumGothic"/>
+              </a:rPr>
+              <a:t>Day 5 · 금</a:t>
+            </a:r>
+            <a:r>
+              <a:rPr sz="900" b="1">
+                <a:solidFill>
+                  <a:srgbClr val="64748B"/>
+                </a:solidFill>
+                <a:latin typeface="NanumGothic"/>
+                <a:ea typeface="NanumGothic"/>
+                <a:cs typeface="NanumGothic"/>
+              </a:rPr>
+              <a:t>   ·   19 / 21</a:t>
             </a:r>
           </a:p>
         </p:txBody>
@@ -13499,54 +13714,7 @@
       </p:sp>
       <p:sp>
         <p:nvSpPr>
-          <p:cNvPr id="8" name="TextBox 7"/>
-          <p:cNvSpPr txBox="1"/>
-          <p:nvPr/>
-        </p:nvSpPr>
-        <p:spPr>
-          <a:xfrm>
-            <a:off x="10241280" y="6419088"/>
-            <a:ext cx="1463040" cy="365760"/>
-          </a:xfrm>
-          <a:prstGeom prst="rect">
-            <a:avLst/>
-          </a:prstGeom>
-          <a:noFill/>
-        </p:spPr>
-        <p:txBody>
-          <a:bodyPr wrap="square" anchor="ctr" lIns="0" rIns="0" tIns="0" bIns="0">
-            <a:spAutoFit/>
-          </a:bodyPr>
-          <a:lstStyle/>
-          <a:p>
-            <a:pPr algn="r">
-              <a:lnSpc>
-                <a:spcPct val="100000"/>
-              </a:lnSpc>
-              <a:spcBef>
-                <a:spcPts val="0"/>
-              </a:spcBef>
-              <a:spcAft>
-                <a:spcPts val="600"/>
-              </a:spcAft>
-            </a:pPr>
-            <a:r>
-              <a:rPr sz="900" b="1">
-                <a:solidFill>
-                  <a:srgbClr val="F43F5E"/>
-                </a:solidFill>
-                <a:latin typeface="NanumGothic"/>
-                <a:ea typeface="NanumGothic"/>
-                <a:cs typeface="NanumGothic"/>
-              </a:rPr>
-              <a:t>Day 5 · 금</a:t>
-            </a:r>
-          </a:p>
-        </p:txBody>
-      </p:sp>
-      <p:sp>
-        <p:nvSpPr>
-          <p:cNvPr id="9" name="Rounded Rectangle 8"/>
+          <p:cNvPr id="8" name="Rounded Rectangle 7"/>
           <p:cNvSpPr/>
           <p:nvPr/>
         </p:nvSpPr>
@@ -13592,7 +13760,7 @@
       </p:sp>
       <p:sp>
         <p:nvSpPr>
-          <p:cNvPr id="10" name="TextBox 9"/>
+          <p:cNvPr id="9" name="TextBox 8"/>
           <p:cNvSpPr txBox="1"/>
           <p:nvPr/>
         </p:nvSpPr>
@@ -13663,7 +13831,7 @@
       </p:sp>
       <p:sp>
         <p:nvSpPr>
-          <p:cNvPr id="11" name="TextBox 10"/>
+          <p:cNvPr id="10" name="TextBox 9"/>
           <p:cNvSpPr txBox="1"/>
           <p:nvPr/>
         </p:nvSpPr>
@@ -13710,7 +13878,7 @@
       </p:sp>
       <p:sp>
         <p:nvSpPr>
-          <p:cNvPr id="12" name="Rounded Rectangle 11"/>
+          <p:cNvPr id="11" name="Rounded Rectangle 10"/>
           <p:cNvSpPr/>
           <p:nvPr/>
         </p:nvSpPr>
@@ -13756,7 +13924,7 @@
       </p:sp>
       <p:sp>
         <p:nvSpPr>
-          <p:cNvPr id="13" name="TextBox 12"/>
+          <p:cNvPr id="12" name="TextBox 11"/>
           <p:cNvSpPr txBox="1"/>
           <p:nvPr/>
         </p:nvSpPr>
@@ -13827,7 +13995,7 @@
       </p:sp>
       <p:sp>
         <p:nvSpPr>
-          <p:cNvPr id="14" name="TextBox 13"/>
+          <p:cNvPr id="13" name="TextBox 12"/>
           <p:cNvSpPr txBox="1"/>
           <p:nvPr/>
         </p:nvSpPr>
@@ -13874,7 +14042,7 @@
       </p:sp>
       <p:sp>
         <p:nvSpPr>
-          <p:cNvPr id="15" name="Rounded Rectangle 14"/>
+          <p:cNvPr id="14" name="Rounded Rectangle 13"/>
           <p:cNvSpPr/>
           <p:nvPr/>
         </p:nvSpPr>
@@ -13920,7 +14088,7 @@
       </p:sp>
       <p:sp>
         <p:nvSpPr>
-          <p:cNvPr id="16" name="TextBox 15"/>
+          <p:cNvPr id="15" name="TextBox 14"/>
           <p:cNvSpPr txBox="1"/>
           <p:nvPr/>
         </p:nvSpPr>
@@ -13991,7 +14159,7 @@
       </p:sp>
       <p:sp>
         <p:nvSpPr>
-          <p:cNvPr id="17" name="TextBox 16"/>
+          <p:cNvPr id="16" name="TextBox 15"/>
           <p:cNvSpPr txBox="1"/>
           <p:nvPr/>
         </p:nvSpPr>
@@ -14038,7 +14206,7 @@
       </p:sp>
       <p:sp>
         <p:nvSpPr>
-          <p:cNvPr id="18" name="Rounded Rectangle 17"/>
+          <p:cNvPr id="17" name="Rounded Rectangle 16"/>
           <p:cNvSpPr/>
           <p:nvPr/>
         </p:nvSpPr>
@@ -14084,7 +14252,7 @@
       </p:sp>
       <p:sp>
         <p:nvSpPr>
-          <p:cNvPr id="19" name="TextBox 18"/>
+          <p:cNvPr id="18" name="TextBox 17"/>
           <p:cNvSpPr txBox="1"/>
           <p:nvPr/>
         </p:nvSpPr>
@@ -14155,7 +14323,7 @@
       </p:sp>
       <p:sp>
         <p:nvSpPr>
-          <p:cNvPr id="20" name="TextBox 19"/>
+          <p:cNvPr id="19" name="TextBox 18"/>
           <p:cNvSpPr txBox="1"/>
           <p:nvPr/>
         </p:nvSpPr>
@@ -14202,7 +14370,7 @@
       </p:sp>
       <p:sp>
         <p:nvSpPr>
-          <p:cNvPr id="21" name="Rounded Rectangle 20"/>
+          <p:cNvPr id="20" name="Rounded Rectangle 19"/>
           <p:cNvSpPr/>
           <p:nvPr/>
         </p:nvSpPr>
@@ -14246,7 +14414,7 @@
       </p:sp>
       <p:sp>
         <p:nvSpPr>
-          <p:cNvPr id="22" name="TextBox 21"/>
+          <p:cNvPr id="21" name="TextBox 20"/>
           <p:cNvSpPr txBox="1"/>
           <p:nvPr/>
         </p:nvSpPr>
@@ -14317,7 +14485,7 @@
       </p:sp>
       <p:sp>
         <p:nvSpPr>
-          <p:cNvPr id="23" name="TextBox 22"/>
+          <p:cNvPr id="22" name="TextBox 21"/>
           <p:cNvSpPr txBox="1"/>
           <p:nvPr/>
         </p:nvSpPr>
@@ -14364,7 +14532,7 @@
       </p:sp>
       <p:sp>
         <p:nvSpPr>
-          <p:cNvPr id="24" name="TextBox 23"/>
+          <p:cNvPr id="23" name="TextBox 22"/>
           <p:cNvSpPr txBox="1"/>
           <p:nvPr/>
         </p:nvSpPr>
@@ -14411,7 +14579,7 @@
       </p:sp>
       <p:sp>
         <p:nvSpPr>
-          <p:cNvPr id="25" name="TextBox 24"/>
+          <p:cNvPr id="24" name="TextBox 23"/>
           <p:cNvSpPr txBox="1"/>
           <p:nvPr/>
         </p:nvSpPr>
@@ -14463,6 +14631,64 @@
                 <a:cs typeface="NanumGothic"/>
               </a:rPr>
               <a:t>이론 → 도구 → 실전 → 결과 → 발표</a:t>
+            </a:r>
+          </a:p>
+        </p:txBody>
+      </p:sp>
+      <p:sp>
+        <p:nvSpPr>
+          <p:cNvPr id="25" name="TextBox 24"/>
+          <p:cNvSpPr txBox="1"/>
+          <p:nvPr/>
+        </p:nvSpPr>
+        <p:spPr>
+          <a:xfrm>
+            <a:off x="8988552" y="6419088"/>
+            <a:ext cx="2697480" cy="365760"/>
+          </a:xfrm>
+          <a:prstGeom prst="rect">
+            <a:avLst/>
+          </a:prstGeom>
+          <a:noFill/>
+        </p:spPr>
+        <p:txBody>
+          <a:bodyPr wrap="square" anchor="ctr" lIns="0" rIns="0" tIns="0" bIns="0">
+            <a:spAutoFit/>
+          </a:bodyPr>
+          <a:lstStyle/>
+          <a:p>
+            <a:pPr algn="r">
+              <a:lnSpc>
+                <a:spcPct val="100000"/>
+              </a:lnSpc>
+              <a:spcBef>
+                <a:spcPts val="0"/>
+              </a:spcBef>
+              <a:spcAft>
+                <a:spcPts val="600"/>
+              </a:spcAft>
+            </a:pPr>
+            <a:r>
+              <a:rPr sz="900" b="1">
+                <a:solidFill>
+                  <a:srgbClr val="F43F5E"/>
+                </a:solidFill>
+                <a:latin typeface="NanumGothic"/>
+                <a:ea typeface="NanumGothic"/>
+                <a:cs typeface="NanumGothic"/>
+              </a:rPr>
+              <a:t>Day 5 · 금</a:t>
+            </a:r>
+            <a:r>
+              <a:rPr sz="900" b="1">
+                <a:solidFill>
+                  <a:srgbClr val="64748B"/>
+                </a:solidFill>
+                <a:latin typeface="NanumGothic"/>
+                <a:ea typeface="NanumGothic"/>
+                <a:cs typeface="NanumGothic"/>
+              </a:rPr>
+              <a:t>   ·   2 / 21</a:t>
             </a:r>
           </a:p>
         </p:txBody>
@@ -14760,54 +14986,7 @@
       </p:sp>
       <p:sp>
         <p:nvSpPr>
-          <p:cNvPr id="8" name="TextBox 7"/>
-          <p:cNvSpPr txBox="1"/>
-          <p:nvPr/>
-        </p:nvSpPr>
-        <p:spPr>
-          <a:xfrm>
-            <a:off x="10241280" y="6419088"/>
-            <a:ext cx="1463040" cy="365760"/>
-          </a:xfrm>
-          <a:prstGeom prst="rect">
-            <a:avLst/>
-          </a:prstGeom>
-          <a:noFill/>
-        </p:spPr>
-        <p:txBody>
-          <a:bodyPr wrap="square" anchor="ctr" lIns="0" rIns="0" tIns="0" bIns="0">
-            <a:spAutoFit/>
-          </a:bodyPr>
-          <a:lstStyle/>
-          <a:p>
-            <a:pPr algn="r">
-              <a:lnSpc>
-                <a:spcPct val="100000"/>
-              </a:lnSpc>
-              <a:spcBef>
-                <a:spcPts val="0"/>
-              </a:spcBef>
-              <a:spcAft>
-                <a:spcPts val="600"/>
-              </a:spcAft>
-            </a:pPr>
-            <a:r>
-              <a:rPr sz="900" b="1">
-                <a:solidFill>
-                  <a:srgbClr val="F43F5E"/>
-                </a:solidFill>
-                <a:latin typeface="NanumGothic"/>
-                <a:ea typeface="NanumGothic"/>
-                <a:cs typeface="NanumGothic"/>
-              </a:rPr>
-              <a:t>Day 5 · 금</a:t>
-            </a:r>
-          </a:p>
-        </p:txBody>
-      </p:sp>
-      <p:sp>
-        <p:nvSpPr>
-          <p:cNvPr id="9" name="Oval 8"/>
+          <p:cNvPr id="8" name="Oval 7"/>
           <p:cNvSpPr/>
           <p:nvPr/>
         </p:nvSpPr>
@@ -14851,7 +15030,7 @@
       </p:sp>
       <p:sp>
         <p:nvSpPr>
-          <p:cNvPr id="10" name="TextBox 9"/>
+          <p:cNvPr id="9" name="TextBox 8"/>
           <p:cNvSpPr txBox="1"/>
           <p:nvPr/>
         </p:nvSpPr>
@@ -14898,7 +15077,7 @@
       </p:sp>
       <p:sp>
         <p:nvSpPr>
-          <p:cNvPr id="11" name="TextBox 10"/>
+          <p:cNvPr id="10" name="TextBox 9"/>
           <p:cNvSpPr txBox="1"/>
           <p:nvPr/>
         </p:nvSpPr>
@@ -14945,7 +15124,7 @@
       </p:sp>
       <p:sp>
         <p:nvSpPr>
-          <p:cNvPr id="12" name="Oval 11"/>
+          <p:cNvPr id="11" name="Oval 10"/>
           <p:cNvSpPr/>
           <p:nvPr/>
         </p:nvSpPr>
@@ -14989,7 +15168,7 @@
       </p:sp>
       <p:sp>
         <p:nvSpPr>
-          <p:cNvPr id="13" name="TextBox 12"/>
+          <p:cNvPr id="12" name="TextBox 11"/>
           <p:cNvSpPr txBox="1"/>
           <p:nvPr/>
         </p:nvSpPr>
@@ -15036,7 +15215,7 @@
       </p:sp>
       <p:sp>
         <p:nvSpPr>
-          <p:cNvPr id="14" name="TextBox 13"/>
+          <p:cNvPr id="13" name="TextBox 12"/>
           <p:cNvSpPr txBox="1"/>
           <p:nvPr/>
         </p:nvSpPr>
@@ -15083,7 +15262,7 @@
       </p:sp>
       <p:sp>
         <p:nvSpPr>
-          <p:cNvPr id="15" name="Oval 14"/>
+          <p:cNvPr id="14" name="Oval 13"/>
           <p:cNvSpPr/>
           <p:nvPr/>
         </p:nvSpPr>
@@ -15127,7 +15306,7 @@
       </p:sp>
       <p:sp>
         <p:nvSpPr>
-          <p:cNvPr id="16" name="TextBox 15"/>
+          <p:cNvPr id="15" name="TextBox 14"/>
           <p:cNvSpPr txBox="1"/>
           <p:nvPr/>
         </p:nvSpPr>
@@ -15174,7 +15353,7 @@
       </p:sp>
       <p:sp>
         <p:nvSpPr>
-          <p:cNvPr id="17" name="TextBox 16"/>
+          <p:cNvPr id="16" name="TextBox 15"/>
           <p:cNvSpPr txBox="1"/>
           <p:nvPr/>
         </p:nvSpPr>
@@ -15221,7 +15400,7 @@
       </p:sp>
       <p:sp>
         <p:nvSpPr>
-          <p:cNvPr id="18" name="Rounded Rectangle 17"/>
+          <p:cNvPr id="17" name="Rounded Rectangle 16"/>
           <p:cNvSpPr/>
           <p:nvPr/>
         </p:nvSpPr>
@@ -15267,7 +15446,7 @@
       </p:sp>
       <p:sp>
         <p:nvSpPr>
-          <p:cNvPr id="19" name="TextBox 18"/>
+          <p:cNvPr id="18" name="TextBox 17"/>
           <p:cNvSpPr txBox="1"/>
           <p:nvPr/>
         </p:nvSpPr>
@@ -15319,6 +15498,64 @@
                 <a:cs typeface="NanumGothic"/>
               </a:rPr>
               <a:t>수료를 축하합니다</a:t>
+            </a:r>
+          </a:p>
+        </p:txBody>
+      </p:sp>
+      <p:sp>
+        <p:nvSpPr>
+          <p:cNvPr id="19" name="TextBox 18"/>
+          <p:cNvSpPr txBox="1"/>
+          <p:nvPr/>
+        </p:nvSpPr>
+        <p:spPr>
+          <a:xfrm>
+            <a:off x="8988552" y="6419088"/>
+            <a:ext cx="2697480" cy="365760"/>
+          </a:xfrm>
+          <a:prstGeom prst="rect">
+            <a:avLst/>
+          </a:prstGeom>
+          <a:noFill/>
+        </p:spPr>
+        <p:txBody>
+          <a:bodyPr wrap="square" anchor="ctr" lIns="0" rIns="0" tIns="0" bIns="0">
+            <a:spAutoFit/>
+          </a:bodyPr>
+          <a:lstStyle/>
+          <a:p>
+            <a:pPr algn="r">
+              <a:lnSpc>
+                <a:spcPct val="100000"/>
+              </a:lnSpc>
+              <a:spcBef>
+                <a:spcPts val="0"/>
+              </a:spcBef>
+              <a:spcAft>
+                <a:spcPts val="600"/>
+              </a:spcAft>
+            </a:pPr>
+            <a:r>
+              <a:rPr sz="900" b="1">
+                <a:solidFill>
+                  <a:srgbClr val="F43F5E"/>
+                </a:solidFill>
+                <a:latin typeface="NanumGothic"/>
+                <a:ea typeface="NanumGothic"/>
+                <a:cs typeface="NanumGothic"/>
+              </a:rPr>
+              <a:t>Day 5 · 금</a:t>
+            </a:r>
+            <a:r>
+              <a:rPr sz="900" b="1">
+                <a:solidFill>
+                  <a:srgbClr val="64748B"/>
+                </a:solidFill>
+                <a:latin typeface="NanumGothic"/>
+                <a:ea typeface="NanumGothic"/>
+                <a:cs typeface="NanumGothic"/>
+              </a:rPr>
+              <a:t>   ·   20 / 21</a:t>
             </a:r>
           </a:p>
         </p:txBody>
@@ -15622,53 +15859,6 @@
         </p:nvSpPr>
         <p:spPr>
           <a:xfrm>
-            <a:off x="10241280" y="6419088"/>
-            <a:ext cx="1463040" cy="365760"/>
-          </a:xfrm>
-          <a:prstGeom prst="rect">
-            <a:avLst/>
-          </a:prstGeom>
-          <a:noFill/>
-        </p:spPr>
-        <p:txBody>
-          <a:bodyPr wrap="square" anchor="ctr" lIns="0" rIns="0" tIns="0" bIns="0">
-            <a:spAutoFit/>
-          </a:bodyPr>
-          <a:lstStyle/>
-          <a:p>
-            <a:pPr algn="r">
-              <a:lnSpc>
-                <a:spcPct val="100000"/>
-              </a:lnSpc>
-              <a:spcBef>
-                <a:spcPts val="0"/>
-              </a:spcBef>
-              <a:spcAft>
-                <a:spcPts val="600"/>
-              </a:spcAft>
-            </a:pPr>
-            <a:r>
-              <a:rPr sz="900" b="1">
-                <a:solidFill>
-                  <a:srgbClr val="F43F5E"/>
-                </a:solidFill>
-                <a:latin typeface="NanumGothic"/>
-                <a:ea typeface="NanumGothic"/>
-                <a:cs typeface="NanumGothic"/>
-              </a:rPr>
-              <a:t>Day 5 · 금</a:t>
-            </a:r>
-          </a:p>
-        </p:txBody>
-      </p:sp>
-      <p:sp>
-        <p:nvSpPr>
-          <p:cNvPr id="9" name="TextBox 8"/>
-          <p:cNvSpPr txBox="1"/>
-          <p:nvPr/>
-        </p:nvSpPr>
-        <p:spPr>
-          <a:xfrm>
             <a:off x="548640" y="1783080"/>
             <a:ext cx="6400800" cy="365760"/>
           </a:xfrm>
@@ -15710,7 +15900,7 @@
       </p:sp>
       <p:sp>
         <p:nvSpPr>
-          <p:cNvPr id="10" name="Oval 9"/>
+          <p:cNvPr id="9" name="Oval 8"/>
           <p:cNvSpPr/>
           <p:nvPr/>
         </p:nvSpPr>
@@ -15754,7 +15944,7 @@
       </p:sp>
       <p:sp>
         <p:nvSpPr>
-          <p:cNvPr id="11" name="TextBox 10"/>
+          <p:cNvPr id="10" name="TextBox 9"/>
           <p:cNvSpPr txBox="1"/>
           <p:nvPr/>
         </p:nvSpPr>
@@ -15801,7 +15991,7 @@
       </p:sp>
       <p:sp>
         <p:nvSpPr>
-          <p:cNvPr id="12" name="Oval 11"/>
+          <p:cNvPr id="11" name="Oval 10"/>
           <p:cNvSpPr/>
           <p:nvPr/>
         </p:nvSpPr>
@@ -15845,7 +16035,7 @@
       </p:sp>
       <p:sp>
         <p:nvSpPr>
-          <p:cNvPr id="13" name="TextBox 12"/>
+          <p:cNvPr id="12" name="TextBox 11"/>
           <p:cNvSpPr txBox="1"/>
           <p:nvPr/>
         </p:nvSpPr>
@@ -15892,7 +16082,7 @@
       </p:sp>
       <p:sp>
         <p:nvSpPr>
-          <p:cNvPr id="14" name="Oval 13"/>
+          <p:cNvPr id="13" name="Oval 12"/>
           <p:cNvSpPr/>
           <p:nvPr/>
         </p:nvSpPr>
@@ -15936,7 +16126,7 @@
       </p:sp>
       <p:sp>
         <p:nvSpPr>
-          <p:cNvPr id="15" name="TextBox 14"/>
+          <p:cNvPr id="14" name="TextBox 13"/>
           <p:cNvSpPr txBox="1"/>
           <p:nvPr/>
         </p:nvSpPr>
@@ -15983,7 +16173,7 @@
       </p:sp>
       <p:sp>
         <p:nvSpPr>
-          <p:cNvPr id="16" name="Rounded Rectangle 15"/>
+          <p:cNvPr id="15" name="Rounded Rectangle 14"/>
           <p:cNvSpPr/>
           <p:nvPr/>
         </p:nvSpPr>
@@ -16029,7 +16219,7 @@
       </p:sp>
       <p:sp>
         <p:nvSpPr>
-          <p:cNvPr id="17" name="TextBox 16"/>
+          <p:cNvPr id="16" name="TextBox 15"/>
           <p:cNvSpPr txBox="1"/>
           <p:nvPr/>
         </p:nvSpPr>
@@ -16076,7 +16266,7 @@
       </p:sp>
       <p:sp>
         <p:nvSpPr>
-          <p:cNvPr id="18" name="TextBox 17"/>
+          <p:cNvPr id="17" name="TextBox 16"/>
           <p:cNvSpPr txBox="1"/>
           <p:nvPr/>
         </p:nvSpPr>
@@ -16117,6 +16307,64 @@
                 <a:cs typeface="NanumGothic"/>
               </a:rPr>
               <a:t>수고하셨습니다. 이제 각자의 문제에 AI 에이전트를 적용할 차례입니다.</a:t>
+            </a:r>
+          </a:p>
+        </p:txBody>
+      </p:sp>
+      <p:sp>
+        <p:nvSpPr>
+          <p:cNvPr id="18" name="TextBox 17"/>
+          <p:cNvSpPr txBox="1"/>
+          <p:nvPr/>
+        </p:nvSpPr>
+        <p:spPr>
+          <a:xfrm>
+            <a:off x="8988552" y="6419088"/>
+            <a:ext cx="2697480" cy="365760"/>
+          </a:xfrm>
+          <a:prstGeom prst="rect">
+            <a:avLst/>
+          </a:prstGeom>
+          <a:noFill/>
+        </p:spPr>
+        <p:txBody>
+          <a:bodyPr wrap="square" anchor="ctr" lIns="0" rIns="0" tIns="0" bIns="0">
+            <a:spAutoFit/>
+          </a:bodyPr>
+          <a:lstStyle/>
+          <a:p>
+            <a:pPr algn="r">
+              <a:lnSpc>
+                <a:spcPct val="100000"/>
+              </a:lnSpc>
+              <a:spcBef>
+                <a:spcPts val="0"/>
+              </a:spcBef>
+              <a:spcAft>
+                <a:spcPts val="600"/>
+              </a:spcAft>
+            </a:pPr>
+            <a:r>
+              <a:rPr sz="900" b="1">
+                <a:solidFill>
+                  <a:srgbClr val="F43F5E"/>
+                </a:solidFill>
+                <a:latin typeface="NanumGothic"/>
+                <a:ea typeface="NanumGothic"/>
+                <a:cs typeface="NanumGothic"/>
+              </a:rPr>
+              <a:t>Day 5 · 금</a:t>
+            </a:r>
+            <a:r>
+              <a:rPr sz="900" b="1">
+                <a:solidFill>
+                  <a:srgbClr val="64748B"/>
+                </a:solidFill>
+                <a:latin typeface="NanumGothic"/>
+                <a:ea typeface="NanumGothic"/>
+                <a:cs typeface="NanumGothic"/>
+              </a:rPr>
+              <a:t>   ·   21 / 21</a:t>
             </a:r>
           </a:p>
         </p:txBody>
@@ -16414,54 +16662,7 @@
       </p:sp>
       <p:sp>
         <p:nvSpPr>
-          <p:cNvPr id="8" name="TextBox 7"/>
-          <p:cNvSpPr txBox="1"/>
-          <p:nvPr/>
-        </p:nvSpPr>
-        <p:spPr>
-          <a:xfrm>
-            <a:off x="10241280" y="6419088"/>
-            <a:ext cx="1463040" cy="365760"/>
-          </a:xfrm>
-          <a:prstGeom prst="rect">
-            <a:avLst/>
-          </a:prstGeom>
-          <a:noFill/>
-        </p:spPr>
-        <p:txBody>
-          <a:bodyPr wrap="square" anchor="ctr" lIns="0" rIns="0" tIns="0" bIns="0">
-            <a:spAutoFit/>
-          </a:bodyPr>
-          <a:lstStyle/>
-          <a:p>
-            <a:pPr algn="r">
-              <a:lnSpc>
-                <a:spcPct val="100000"/>
-              </a:lnSpc>
-              <a:spcBef>
-                <a:spcPts val="0"/>
-              </a:spcBef>
-              <a:spcAft>
-                <a:spcPts val="600"/>
-              </a:spcAft>
-            </a:pPr>
-            <a:r>
-              <a:rPr sz="900" b="1">
-                <a:solidFill>
-                  <a:srgbClr val="F43F5E"/>
-                </a:solidFill>
-                <a:latin typeface="NanumGothic"/>
-                <a:ea typeface="NanumGothic"/>
-                <a:cs typeface="NanumGothic"/>
-              </a:rPr>
-              <a:t>Day 5 · 금</a:t>
-            </a:r>
-          </a:p>
-        </p:txBody>
-      </p:sp>
-      <p:sp>
-        <p:nvSpPr>
-          <p:cNvPr id="9" name="Rounded Rectangle 8"/>
+          <p:cNvPr id="8" name="Rounded Rectangle 7"/>
           <p:cNvSpPr/>
           <p:nvPr/>
         </p:nvSpPr>
@@ -16507,7 +16708,7 @@
       </p:sp>
       <p:sp>
         <p:nvSpPr>
-          <p:cNvPr id="10" name="Rectangle 9"/>
+          <p:cNvPr id="9" name="Rectangle 8"/>
           <p:cNvSpPr/>
           <p:nvPr/>
         </p:nvSpPr>
@@ -16551,7 +16752,7 @@
       </p:sp>
       <p:sp>
         <p:nvSpPr>
-          <p:cNvPr id="11" name="Oval 10"/>
+          <p:cNvPr id="10" name="Oval 9"/>
           <p:cNvSpPr/>
           <p:nvPr/>
         </p:nvSpPr>
@@ -16595,7 +16796,7 @@
       </p:sp>
       <p:sp>
         <p:nvSpPr>
-          <p:cNvPr id="12" name="TextBox 11"/>
+          <p:cNvPr id="11" name="TextBox 10"/>
           <p:cNvSpPr txBox="1"/>
           <p:nvPr/>
         </p:nvSpPr>
@@ -16642,7 +16843,7 @@
       </p:sp>
       <p:sp>
         <p:nvSpPr>
-          <p:cNvPr id="13" name="TextBox 12"/>
+          <p:cNvPr id="12" name="TextBox 11"/>
           <p:cNvSpPr txBox="1"/>
           <p:nvPr/>
         </p:nvSpPr>
@@ -16689,7 +16890,7 @@
       </p:sp>
       <p:sp>
         <p:nvSpPr>
-          <p:cNvPr id="14" name="TextBox 13"/>
+          <p:cNvPr id="13" name="TextBox 12"/>
           <p:cNvSpPr txBox="1"/>
           <p:nvPr/>
         </p:nvSpPr>
@@ -16747,7 +16948,7 @@
       </p:sp>
       <p:sp>
         <p:nvSpPr>
-          <p:cNvPr id="15" name="TextBox 14"/>
+          <p:cNvPr id="14" name="TextBox 13"/>
           <p:cNvSpPr txBox="1"/>
           <p:nvPr/>
         </p:nvSpPr>
@@ -16794,7 +16995,7 @@
       </p:sp>
       <p:sp>
         <p:nvSpPr>
-          <p:cNvPr id="16" name="TextBox 15"/>
+          <p:cNvPr id="15" name="TextBox 14"/>
           <p:cNvSpPr txBox="1"/>
           <p:nvPr/>
         </p:nvSpPr>
@@ -16841,7 +17042,7 @@
       </p:sp>
       <p:sp>
         <p:nvSpPr>
-          <p:cNvPr id="17" name="Rounded Rectangle 16"/>
+          <p:cNvPr id="16" name="Rounded Rectangle 15"/>
           <p:cNvSpPr/>
           <p:nvPr/>
         </p:nvSpPr>
@@ -16887,7 +17088,7 @@
       </p:sp>
       <p:sp>
         <p:nvSpPr>
-          <p:cNvPr id="18" name="Rectangle 17"/>
+          <p:cNvPr id="17" name="Rectangle 16"/>
           <p:cNvSpPr/>
           <p:nvPr/>
         </p:nvSpPr>
@@ -16931,7 +17132,7 @@
       </p:sp>
       <p:sp>
         <p:nvSpPr>
-          <p:cNvPr id="19" name="Oval 18"/>
+          <p:cNvPr id="18" name="Oval 17"/>
           <p:cNvSpPr/>
           <p:nvPr/>
         </p:nvSpPr>
@@ -16975,7 +17176,7 @@
       </p:sp>
       <p:sp>
         <p:nvSpPr>
-          <p:cNvPr id="20" name="TextBox 19"/>
+          <p:cNvPr id="19" name="TextBox 18"/>
           <p:cNvSpPr txBox="1"/>
           <p:nvPr/>
         </p:nvSpPr>
@@ -17022,7 +17223,7 @@
       </p:sp>
       <p:sp>
         <p:nvSpPr>
-          <p:cNvPr id="21" name="TextBox 20"/>
+          <p:cNvPr id="20" name="TextBox 19"/>
           <p:cNvSpPr txBox="1"/>
           <p:nvPr/>
         </p:nvSpPr>
@@ -17069,7 +17270,7 @@
       </p:sp>
       <p:sp>
         <p:nvSpPr>
-          <p:cNvPr id="22" name="TextBox 21"/>
+          <p:cNvPr id="21" name="TextBox 20"/>
           <p:cNvSpPr txBox="1"/>
           <p:nvPr/>
         </p:nvSpPr>
@@ -17127,7 +17328,7 @@
       </p:sp>
       <p:sp>
         <p:nvSpPr>
-          <p:cNvPr id="23" name="TextBox 22"/>
+          <p:cNvPr id="22" name="TextBox 21"/>
           <p:cNvSpPr txBox="1"/>
           <p:nvPr/>
         </p:nvSpPr>
@@ -17174,7 +17375,7 @@
       </p:sp>
       <p:sp>
         <p:nvSpPr>
-          <p:cNvPr id="24" name="TextBox 23"/>
+          <p:cNvPr id="23" name="TextBox 22"/>
           <p:cNvSpPr txBox="1"/>
           <p:nvPr/>
         </p:nvSpPr>
@@ -17221,7 +17422,7 @@
       </p:sp>
       <p:sp>
         <p:nvSpPr>
-          <p:cNvPr id="25" name="Rounded Rectangle 24"/>
+          <p:cNvPr id="24" name="Rounded Rectangle 23"/>
           <p:cNvSpPr/>
           <p:nvPr/>
         </p:nvSpPr>
@@ -17267,7 +17468,7 @@
       </p:sp>
       <p:sp>
         <p:nvSpPr>
-          <p:cNvPr id="26" name="Rectangle 25"/>
+          <p:cNvPr id="25" name="Rectangle 24"/>
           <p:cNvSpPr/>
           <p:nvPr/>
         </p:nvSpPr>
@@ -17311,7 +17512,7 @@
       </p:sp>
       <p:sp>
         <p:nvSpPr>
-          <p:cNvPr id="27" name="Oval 26"/>
+          <p:cNvPr id="26" name="Oval 25"/>
           <p:cNvSpPr/>
           <p:nvPr/>
         </p:nvSpPr>
@@ -17355,7 +17556,7 @@
       </p:sp>
       <p:sp>
         <p:nvSpPr>
-          <p:cNvPr id="28" name="TextBox 27"/>
+          <p:cNvPr id="27" name="TextBox 26"/>
           <p:cNvSpPr txBox="1"/>
           <p:nvPr/>
         </p:nvSpPr>
@@ -17402,7 +17603,7 @@
       </p:sp>
       <p:sp>
         <p:nvSpPr>
-          <p:cNvPr id="29" name="TextBox 28"/>
+          <p:cNvPr id="28" name="TextBox 27"/>
           <p:cNvSpPr txBox="1"/>
           <p:nvPr/>
         </p:nvSpPr>
@@ -17449,7 +17650,7 @@
       </p:sp>
       <p:sp>
         <p:nvSpPr>
-          <p:cNvPr id="30" name="TextBox 29"/>
+          <p:cNvPr id="29" name="TextBox 28"/>
           <p:cNvSpPr txBox="1"/>
           <p:nvPr/>
         </p:nvSpPr>
@@ -17507,7 +17708,7 @@
       </p:sp>
       <p:sp>
         <p:nvSpPr>
-          <p:cNvPr id="31" name="TextBox 30"/>
+          <p:cNvPr id="30" name="TextBox 29"/>
           <p:cNvSpPr txBox="1"/>
           <p:nvPr/>
         </p:nvSpPr>
@@ -17554,7 +17755,7 @@
       </p:sp>
       <p:sp>
         <p:nvSpPr>
-          <p:cNvPr id="32" name="TextBox 31"/>
+          <p:cNvPr id="31" name="TextBox 30"/>
           <p:cNvSpPr txBox="1"/>
           <p:nvPr/>
         </p:nvSpPr>
@@ -17595,6 +17796,64 @@
                 <a:cs typeface="NanumGothic"/>
               </a:rPr>
               <a:t>90분</a:t>
+            </a:r>
+          </a:p>
+        </p:txBody>
+      </p:sp>
+      <p:sp>
+        <p:nvSpPr>
+          <p:cNvPr id="32" name="TextBox 31"/>
+          <p:cNvSpPr txBox="1"/>
+          <p:nvPr/>
+        </p:nvSpPr>
+        <p:spPr>
+          <a:xfrm>
+            <a:off x="8988552" y="6419088"/>
+            <a:ext cx="2697480" cy="365760"/>
+          </a:xfrm>
+          <a:prstGeom prst="rect">
+            <a:avLst/>
+          </a:prstGeom>
+          <a:noFill/>
+        </p:spPr>
+        <p:txBody>
+          <a:bodyPr wrap="square" anchor="ctr" lIns="0" rIns="0" tIns="0" bIns="0">
+            <a:spAutoFit/>
+          </a:bodyPr>
+          <a:lstStyle/>
+          <a:p>
+            <a:pPr algn="r">
+              <a:lnSpc>
+                <a:spcPct val="100000"/>
+              </a:lnSpc>
+              <a:spcBef>
+                <a:spcPts val="0"/>
+              </a:spcBef>
+              <a:spcAft>
+                <a:spcPts val="600"/>
+              </a:spcAft>
+            </a:pPr>
+            <a:r>
+              <a:rPr sz="900" b="1">
+                <a:solidFill>
+                  <a:srgbClr val="F43F5E"/>
+                </a:solidFill>
+                <a:latin typeface="NanumGothic"/>
+                <a:ea typeface="NanumGothic"/>
+                <a:cs typeface="NanumGothic"/>
+              </a:rPr>
+              <a:t>Day 5 · 금</a:t>
+            </a:r>
+            <a:r>
+              <a:rPr sz="900" b="1">
+                <a:solidFill>
+                  <a:srgbClr val="64748B"/>
+                </a:solidFill>
+                <a:latin typeface="NanumGothic"/>
+                <a:ea typeface="NanumGothic"/>
+                <a:cs typeface="NanumGothic"/>
+              </a:rPr>
+              <a:t>   ·   3 / 21</a:t>
             </a:r>
           </a:p>
         </p:txBody>
@@ -17901,6 +18160,64 @@
           </a:p>
         </p:txBody>
       </p:sp>
+      <p:sp>
+        <p:nvSpPr>
+          <p:cNvPr id="8" name="TextBox 7"/>
+          <p:cNvSpPr txBox="1"/>
+          <p:nvPr/>
+        </p:nvSpPr>
+        <p:spPr>
+          <a:xfrm>
+            <a:off x="8988552" y="6419088"/>
+            <a:ext cx="2697480" cy="365760"/>
+          </a:xfrm>
+          <a:prstGeom prst="rect">
+            <a:avLst/>
+          </a:prstGeom>
+          <a:noFill/>
+        </p:spPr>
+        <p:txBody>
+          <a:bodyPr wrap="square" anchor="ctr" lIns="0" rIns="0" tIns="0" bIns="0">
+            <a:spAutoFit/>
+          </a:bodyPr>
+          <a:lstStyle/>
+          <a:p>
+            <a:pPr algn="r">
+              <a:lnSpc>
+                <a:spcPct val="100000"/>
+              </a:lnSpc>
+              <a:spcBef>
+                <a:spcPts val="0"/>
+              </a:spcBef>
+              <a:spcAft>
+                <a:spcPts val="600"/>
+              </a:spcAft>
+            </a:pPr>
+            <a:r>
+              <a:rPr sz="900" b="1">
+                <a:solidFill>
+                  <a:srgbClr val="F43F5E"/>
+                </a:solidFill>
+                <a:latin typeface="NanumGothic"/>
+                <a:ea typeface="NanumGothic"/>
+                <a:cs typeface="NanumGothic"/>
+              </a:rPr>
+              <a:t>Day 5 · 금</a:t>
+            </a:r>
+            <a:r>
+              <a:rPr sz="900" b="1">
+                <a:solidFill>
+                  <a:srgbClr val="CBD5E1"/>
+                </a:solidFill>
+                <a:latin typeface="NanumGothic"/>
+                <a:ea typeface="NanumGothic"/>
+                <a:cs typeface="NanumGothic"/>
+              </a:rPr>
+              <a:t>   ·   4 / 21</a:t>
+            </a:r>
+          </a:p>
+        </p:txBody>
+      </p:sp>
     </p:spTree>
   </p:cSld>
   <p:clrMapOvr>
@@ -18194,54 +18511,7 @@
       </p:sp>
       <p:sp>
         <p:nvSpPr>
-          <p:cNvPr id="8" name="TextBox 7"/>
-          <p:cNvSpPr txBox="1"/>
-          <p:nvPr/>
-        </p:nvSpPr>
-        <p:spPr>
-          <a:xfrm>
-            <a:off x="10241280" y="6419088"/>
-            <a:ext cx="1463040" cy="365760"/>
-          </a:xfrm>
-          <a:prstGeom prst="rect">
-            <a:avLst/>
-          </a:prstGeom>
-          <a:noFill/>
-        </p:spPr>
-        <p:txBody>
-          <a:bodyPr wrap="square" anchor="ctr" lIns="0" rIns="0" tIns="0" bIns="0">
-            <a:spAutoFit/>
-          </a:bodyPr>
-          <a:lstStyle/>
-          <a:p>
-            <a:pPr algn="r">
-              <a:lnSpc>
-                <a:spcPct val="100000"/>
-              </a:lnSpc>
-              <a:spcBef>
-                <a:spcPts val="0"/>
-              </a:spcBef>
-              <a:spcAft>
-                <a:spcPts val="600"/>
-              </a:spcAft>
-            </a:pPr>
-            <a:r>
-              <a:rPr sz="900" b="1">
-                <a:solidFill>
-                  <a:srgbClr val="F43F5E"/>
-                </a:solidFill>
-                <a:latin typeface="NanumGothic"/>
-                <a:ea typeface="NanumGothic"/>
-                <a:cs typeface="NanumGothic"/>
-              </a:rPr>
-              <a:t>Day 5 · 금</a:t>
-            </a:r>
-          </a:p>
-        </p:txBody>
-      </p:sp>
-      <p:sp>
-        <p:nvSpPr>
-          <p:cNvPr id="9" name="Rounded Rectangle 8"/>
+          <p:cNvPr id="8" name="Rounded Rectangle 7"/>
           <p:cNvSpPr/>
           <p:nvPr/>
         </p:nvSpPr>
@@ -18287,7 +18557,7 @@
       </p:sp>
       <p:sp>
         <p:nvSpPr>
-          <p:cNvPr id="10" name="TextBox 9"/>
+          <p:cNvPr id="9" name="TextBox 8"/>
           <p:cNvSpPr txBox="1"/>
           <p:nvPr/>
         </p:nvSpPr>
@@ -18334,7 +18604,7 @@
       </p:sp>
       <p:sp>
         <p:nvSpPr>
-          <p:cNvPr id="11" name="TextBox 10"/>
+          <p:cNvPr id="10" name="TextBox 9"/>
           <p:cNvSpPr txBox="1"/>
           <p:nvPr/>
         </p:nvSpPr>
@@ -18381,7 +18651,7 @@
       </p:sp>
       <p:sp>
         <p:nvSpPr>
-          <p:cNvPr id="12" name="Rounded Rectangle 11"/>
+          <p:cNvPr id="11" name="Rounded Rectangle 10"/>
           <p:cNvSpPr/>
           <p:nvPr/>
         </p:nvSpPr>
@@ -18427,7 +18697,7 @@
       </p:sp>
       <p:sp>
         <p:nvSpPr>
-          <p:cNvPr id="13" name="Oval 12"/>
+          <p:cNvPr id="12" name="Oval 11"/>
           <p:cNvSpPr/>
           <p:nvPr/>
         </p:nvSpPr>
@@ -18471,7 +18741,7 @@
       </p:sp>
       <p:sp>
         <p:nvSpPr>
-          <p:cNvPr id="14" name="TextBox 13"/>
+          <p:cNvPr id="13" name="TextBox 12"/>
           <p:cNvSpPr txBox="1"/>
           <p:nvPr/>
         </p:nvSpPr>
@@ -18518,7 +18788,7 @@
       </p:sp>
       <p:sp>
         <p:nvSpPr>
-          <p:cNvPr id="15" name="TextBox 14"/>
+          <p:cNvPr id="14" name="TextBox 13"/>
           <p:cNvSpPr txBox="1"/>
           <p:nvPr/>
         </p:nvSpPr>
@@ -18565,7 +18835,7 @@
       </p:sp>
       <p:sp>
         <p:nvSpPr>
-          <p:cNvPr id="16" name="Rounded Rectangle 15"/>
+          <p:cNvPr id="15" name="Rounded Rectangle 14"/>
           <p:cNvSpPr/>
           <p:nvPr/>
         </p:nvSpPr>
@@ -18611,7 +18881,7 @@
       </p:sp>
       <p:sp>
         <p:nvSpPr>
-          <p:cNvPr id="17" name="Oval 16"/>
+          <p:cNvPr id="16" name="Oval 15"/>
           <p:cNvSpPr/>
           <p:nvPr/>
         </p:nvSpPr>
@@ -18655,7 +18925,7 @@
       </p:sp>
       <p:sp>
         <p:nvSpPr>
-          <p:cNvPr id="18" name="TextBox 17"/>
+          <p:cNvPr id="17" name="TextBox 16"/>
           <p:cNvSpPr txBox="1"/>
           <p:nvPr/>
         </p:nvSpPr>
@@ -18702,7 +18972,7 @@
       </p:sp>
       <p:sp>
         <p:nvSpPr>
-          <p:cNvPr id="19" name="TextBox 18"/>
+          <p:cNvPr id="18" name="TextBox 17"/>
           <p:cNvSpPr txBox="1"/>
           <p:nvPr/>
         </p:nvSpPr>
@@ -18749,7 +19019,7 @@
       </p:sp>
       <p:sp>
         <p:nvSpPr>
-          <p:cNvPr id="20" name="Rounded Rectangle 19"/>
+          <p:cNvPr id="19" name="Rounded Rectangle 18"/>
           <p:cNvSpPr/>
           <p:nvPr/>
         </p:nvSpPr>
@@ -18795,7 +19065,7 @@
       </p:sp>
       <p:sp>
         <p:nvSpPr>
-          <p:cNvPr id="21" name="Oval 20"/>
+          <p:cNvPr id="20" name="Oval 19"/>
           <p:cNvSpPr/>
           <p:nvPr/>
         </p:nvSpPr>
@@ -18839,7 +19109,7 @@
       </p:sp>
       <p:sp>
         <p:nvSpPr>
-          <p:cNvPr id="22" name="TextBox 21"/>
+          <p:cNvPr id="21" name="TextBox 20"/>
           <p:cNvSpPr txBox="1"/>
           <p:nvPr/>
         </p:nvSpPr>
@@ -18886,7 +19156,7 @@
       </p:sp>
       <p:sp>
         <p:nvSpPr>
-          <p:cNvPr id="23" name="TextBox 22"/>
+          <p:cNvPr id="22" name="TextBox 21"/>
           <p:cNvSpPr txBox="1"/>
           <p:nvPr/>
         </p:nvSpPr>
@@ -18927,6 +19197,64 @@
                 <a:cs typeface="NanumGothic"/>
               </a:rPr>
               <a:t>발표 준비</a:t>
+            </a:r>
+          </a:p>
+        </p:txBody>
+      </p:sp>
+      <p:sp>
+        <p:nvSpPr>
+          <p:cNvPr id="23" name="TextBox 22"/>
+          <p:cNvSpPr txBox="1"/>
+          <p:nvPr/>
+        </p:nvSpPr>
+        <p:spPr>
+          <a:xfrm>
+            <a:off x="8988552" y="6419088"/>
+            <a:ext cx="2697480" cy="365760"/>
+          </a:xfrm>
+          <a:prstGeom prst="rect">
+            <a:avLst/>
+          </a:prstGeom>
+          <a:noFill/>
+        </p:spPr>
+        <p:txBody>
+          <a:bodyPr wrap="square" anchor="ctr" lIns="0" rIns="0" tIns="0" bIns="0">
+            <a:spAutoFit/>
+          </a:bodyPr>
+          <a:lstStyle/>
+          <a:p>
+            <a:pPr algn="r">
+              <a:lnSpc>
+                <a:spcPct val="100000"/>
+              </a:lnSpc>
+              <a:spcBef>
+                <a:spcPts val="0"/>
+              </a:spcBef>
+              <a:spcAft>
+                <a:spcPts val="600"/>
+              </a:spcAft>
+            </a:pPr>
+            <a:r>
+              <a:rPr sz="900" b="1">
+                <a:solidFill>
+                  <a:srgbClr val="F43F5E"/>
+                </a:solidFill>
+                <a:latin typeface="NanumGothic"/>
+                <a:ea typeface="NanumGothic"/>
+                <a:cs typeface="NanumGothic"/>
+              </a:rPr>
+              <a:t>Day 5 · 금</a:t>
+            </a:r>
+            <a:r>
+              <a:rPr sz="900" b="1">
+                <a:solidFill>
+                  <a:srgbClr val="64748B"/>
+                </a:solidFill>
+                <a:latin typeface="NanumGothic"/>
+                <a:ea typeface="NanumGothic"/>
+                <a:cs typeface="NanumGothic"/>
+              </a:rPr>
+              <a:t>   ·   5 / 21</a:t>
             </a:r>
           </a:p>
         </p:txBody>
@@ -19224,54 +19552,7 @@
       </p:sp>
       <p:sp>
         <p:nvSpPr>
-          <p:cNvPr id="8" name="TextBox 7"/>
-          <p:cNvSpPr txBox="1"/>
-          <p:nvPr/>
-        </p:nvSpPr>
-        <p:spPr>
-          <a:xfrm>
-            <a:off x="10241280" y="6419088"/>
-            <a:ext cx="1463040" cy="365760"/>
-          </a:xfrm>
-          <a:prstGeom prst="rect">
-            <a:avLst/>
-          </a:prstGeom>
-          <a:noFill/>
-        </p:spPr>
-        <p:txBody>
-          <a:bodyPr wrap="square" anchor="ctr" lIns="0" rIns="0" tIns="0" bIns="0">
-            <a:spAutoFit/>
-          </a:bodyPr>
-          <a:lstStyle/>
-          <a:p>
-            <a:pPr algn="r">
-              <a:lnSpc>
-                <a:spcPct val="100000"/>
-              </a:lnSpc>
-              <a:spcBef>
-                <a:spcPts val="0"/>
-              </a:spcBef>
-              <a:spcAft>
-                <a:spcPts val="600"/>
-              </a:spcAft>
-            </a:pPr>
-            <a:r>
-              <a:rPr sz="900" b="1">
-                <a:solidFill>
-                  <a:srgbClr val="F43F5E"/>
-                </a:solidFill>
-                <a:latin typeface="NanumGothic"/>
-                <a:ea typeface="NanumGothic"/>
-                <a:cs typeface="NanumGothic"/>
-              </a:rPr>
-              <a:t>Day 5 · 금</a:t>
-            </a:r>
-          </a:p>
-        </p:txBody>
-      </p:sp>
-      <p:sp>
-        <p:nvSpPr>
-          <p:cNvPr id="9" name="Oval 8"/>
+          <p:cNvPr id="8" name="Oval 7"/>
           <p:cNvSpPr/>
           <p:nvPr/>
         </p:nvSpPr>
@@ -19315,7 +19596,7 @@
       </p:sp>
       <p:sp>
         <p:nvSpPr>
-          <p:cNvPr id="10" name="TextBox 9"/>
+          <p:cNvPr id="9" name="TextBox 8"/>
           <p:cNvSpPr txBox="1"/>
           <p:nvPr/>
         </p:nvSpPr>
@@ -19362,7 +19643,7 @@
       </p:sp>
       <p:sp>
         <p:nvSpPr>
-          <p:cNvPr id="11" name="TextBox 10"/>
+          <p:cNvPr id="10" name="TextBox 9"/>
           <p:cNvSpPr txBox="1"/>
           <p:nvPr/>
         </p:nvSpPr>
@@ -19409,7 +19690,7 @@
       </p:sp>
       <p:sp>
         <p:nvSpPr>
-          <p:cNvPr id="12" name="Oval 11"/>
+          <p:cNvPr id="11" name="Oval 10"/>
           <p:cNvSpPr/>
           <p:nvPr/>
         </p:nvSpPr>
@@ -19453,7 +19734,7 @@
       </p:sp>
       <p:sp>
         <p:nvSpPr>
-          <p:cNvPr id="13" name="TextBox 12"/>
+          <p:cNvPr id="12" name="TextBox 11"/>
           <p:cNvSpPr txBox="1"/>
           <p:nvPr/>
         </p:nvSpPr>
@@ -19500,7 +19781,7 @@
       </p:sp>
       <p:sp>
         <p:nvSpPr>
-          <p:cNvPr id="14" name="TextBox 13"/>
+          <p:cNvPr id="13" name="TextBox 12"/>
           <p:cNvSpPr txBox="1"/>
           <p:nvPr/>
         </p:nvSpPr>
@@ -19547,7 +19828,7 @@
       </p:sp>
       <p:sp>
         <p:nvSpPr>
-          <p:cNvPr id="15" name="Oval 14"/>
+          <p:cNvPr id="14" name="Oval 13"/>
           <p:cNvSpPr/>
           <p:nvPr/>
         </p:nvSpPr>
@@ -19591,7 +19872,7 @@
       </p:sp>
       <p:sp>
         <p:nvSpPr>
-          <p:cNvPr id="16" name="TextBox 15"/>
+          <p:cNvPr id="15" name="TextBox 14"/>
           <p:cNvSpPr txBox="1"/>
           <p:nvPr/>
         </p:nvSpPr>
@@ -19638,7 +19919,7 @@
       </p:sp>
       <p:sp>
         <p:nvSpPr>
-          <p:cNvPr id="17" name="TextBox 16"/>
+          <p:cNvPr id="16" name="TextBox 15"/>
           <p:cNvSpPr txBox="1"/>
           <p:nvPr/>
         </p:nvSpPr>
@@ -19685,7 +19966,7 @@
       </p:sp>
       <p:sp>
         <p:nvSpPr>
-          <p:cNvPr id="18" name="Rounded Rectangle 17"/>
+          <p:cNvPr id="17" name="Rounded Rectangle 16"/>
           <p:cNvSpPr/>
           <p:nvPr/>
         </p:nvSpPr>
@@ -19731,7 +20012,7 @@
       </p:sp>
       <p:sp>
         <p:nvSpPr>
-          <p:cNvPr id="19" name="TextBox 18"/>
+          <p:cNvPr id="18" name="TextBox 17"/>
           <p:cNvSpPr txBox="1"/>
           <p:nvPr/>
         </p:nvSpPr>
@@ -19783,6 +20064,64 @@
                 <a:cs typeface="NanumGothic"/>
               </a:rPr>
               <a:t>버퍼는 팀별 진척에 맞게 유연하게</a:t>
+            </a:r>
+          </a:p>
+        </p:txBody>
+      </p:sp>
+      <p:sp>
+        <p:nvSpPr>
+          <p:cNvPr id="19" name="TextBox 18"/>
+          <p:cNvSpPr txBox="1"/>
+          <p:nvPr/>
+        </p:nvSpPr>
+        <p:spPr>
+          <a:xfrm>
+            <a:off x="8988552" y="6419088"/>
+            <a:ext cx="2697480" cy="365760"/>
+          </a:xfrm>
+          <a:prstGeom prst="rect">
+            <a:avLst/>
+          </a:prstGeom>
+          <a:noFill/>
+        </p:spPr>
+        <p:txBody>
+          <a:bodyPr wrap="square" anchor="ctr" lIns="0" rIns="0" tIns="0" bIns="0">
+            <a:spAutoFit/>
+          </a:bodyPr>
+          <a:lstStyle/>
+          <a:p>
+            <a:pPr algn="r">
+              <a:lnSpc>
+                <a:spcPct val="100000"/>
+              </a:lnSpc>
+              <a:spcBef>
+                <a:spcPts val="0"/>
+              </a:spcBef>
+              <a:spcAft>
+                <a:spcPts val="600"/>
+              </a:spcAft>
+            </a:pPr>
+            <a:r>
+              <a:rPr sz="900" b="1">
+                <a:solidFill>
+                  <a:srgbClr val="F43F5E"/>
+                </a:solidFill>
+                <a:latin typeface="NanumGothic"/>
+                <a:ea typeface="NanumGothic"/>
+                <a:cs typeface="NanumGothic"/>
+              </a:rPr>
+              <a:t>Day 5 · 금</a:t>
+            </a:r>
+            <a:r>
+              <a:rPr sz="900" b="1">
+                <a:solidFill>
+                  <a:srgbClr val="64748B"/>
+                </a:solidFill>
+                <a:latin typeface="NanumGothic"/>
+                <a:ea typeface="NanumGothic"/>
+                <a:cs typeface="NanumGothic"/>
+              </a:rPr>
+              <a:t>   ·   6 / 21</a:t>
             </a:r>
           </a:p>
         </p:txBody>
@@ -20080,54 +20419,7 @@
       </p:sp>
       <p:sp>
         <p:nvSpPr>
-          <p:cNvPr id="8" name="TextBox 7"/>
-          <p:cNvSpPr txBox="1"/>
-          <p:nvPr/>
-        </p:nvSpPr>
-        <p:spPr>
-          <a:xfrm>
-            <a:off x="10241280" y="6419088"/>
-            <a:ext cx="1463040" cy="365760"/>
-          </a:xfrm>
-          <a:prstGeom prst="rect">
-            <a:avLst/>
-          </a:prstGeom>
-          <a:noFill/>
-        </p:spPr>
-        <p:txBody>
-          <a:bodyPr wrap="square" anchor="ctr" lIns="0" rIns="0" tIns="0" bIns="0">
-            <a:spAutoFit/>
-          </a:bodyPr>
-          <a:lstStyle/>
-          <a:p>
-            <a:pPr algn="r">
-              <a:lnSpc>
-                <a:spcPct val="100000"/>
-              </a:lnSpc>
-              <a:spcBef>
-                <a:spcPts val="0"/>
-              </a:spcBef>
-              <a:spcAft>
-                <a:spcPts val="600"/>
-              </a:spcAft>
-            </a:pPr>
-            <a:r>
-              <a:rPr sz="900" b="1">
-                <a:solidFill>
-                  <a:srgbClr val="F43F5E"/>
-                </a:solidFill>
-                <a:latin typeface="NanumGothic"/>
-                <a:ea typeface="NanumGothic"/>
-                <a:cs typeface="NanumGothic"/>
-              </a:rPr>
-              <a:t>Day 5 · 금</a:t>
-            </a:r>
-          </a:p>
-        </p:txBody>
-      </p:sp>
-      <p:sp>
-        <p:nvSpPr>
-          <p:cNvPr id="9" name="Rounded Rectangle 8"/>
+          <p:cNvPr id="8" name="Rounded Rectangle 7"/>
           <p:cNvSpPr/>
           <p:nvPr/>
         </p:nvSpPr>
@@ -20173,7 +20465,7 @@
       </p:sp>
       <p:sp>
         <p:nvSpPr>
-          <p:cNvPr id="10" name="TextBox 9"/>
+          <p:cNvPr id="9" name="TextBox 8"/>
           <p:cNvSpPr txBox="1"/>
           <p:nvPr/>
         </p:nvSpPr>
@@ -20220,7 +20512,7 @@
       </p:sp>
       <p:sp>
         <p:nvSpPr>
-          <p:cNvPr id="11" name="Oval 10"/>
+          <p:cNvPr id="10" name="Oval 9"/>
           <p:cNvSpPr/>
           <p:nvPr/>
         </p:nvSpPr>
@@ -20264,7 +20556,7 @@
       </p:sp>
       <p:sp>
         <p:nvSpPr>
-          <p:cNvPr id="12" name="TextBox 11"/>
+          <p:cNvPr id="11" name="TextBox 10"/>
           <p:cNvSpPr txBox="1"/>
           <p:nvPr/>
         </p:nvSpPr>
@@ -20311,7 +20603,7 @@
       </p:sp>
       <p:sp>
         <p:nvSpPr>
-          <p:cNvPr id="13" name="TextBox 12"/>
+          <p:cNvPr id="12" name="TextBox 11"/>
           <p:cNvSpPr txBox="1"/>
           <p:nvPr/>
         </p:nvSpPr>
@@ -20358,7 +20650,7 @@
       </p:sp>
       <p:sp>
         <p:nvSpPr>
-          <p:cNvPr id="14" name="Oval 13"/>
+          <p:cNvPr id="13" name="Oval 12"/>
           <p:cNvSpPr/>
           <p:nvPr/>
         </p:nvSpPr>
@@ -20402,7 +20694,7 @@
       </p:sp>
       <p:sp>
         <p:nvSpPr>
-          <p:cNvPr id="15" name="TextBox 14"/>
+          <p:cNvPr id="14" name="TextBox 13"/>
           <p:cNvSpPr txBox="1"/>
           <p:nvPr/>
         </p:nvSpPr>
@@ -20449,7 +20741,7 @@
       </p:sp>
       <p:sp>
         <p:nvSpPr>
-          <p:cNvPr id="16" name="TextBox 15"/>
+          <p:cNvPr id="15" name="TextBox 14"/>
           <p:cNvSpPr txBox="1"/>
           <p:nvPr/>
         </p:nvSpPr>
@@ -20496,7 +20788,7 @@
       </p:sp>
       <p:sp>
         <p:nvSpPr>
-          <p:cNvPr id="17" name="Oval 16"/>
+          <p:cNvPr id="16" name="Oval 15"/>
           <p:cNvSpPr/>
           <p:nvPr/>
         </p:nvSpPr>
@@ -20540,7 +20832,7 @@
       </p:sp>
       <p:sp>
         <p:nvSpPr>
-          <p:cNvPr id="18" name="TextBox 17"/>
+          <p:cNvPr id="17" name="TextBox 16"/>
           <p:cNvSpPr txBox="1"/>
           <p:nvPr/>
         </p:nvSpPr>
@@ -20587,7 +20879,7 @@
       </p:sp>
       <p:sp>
         <p:nvSpPr>
-          <p:cNvPr id="19" name="TextBox 18"/>
+          <p:cNvPr id="18" name="TextBox 17"/>
           <p:cNvSpPr txBox="1"/>
           <p:nvPr/>
         </p:nvSpPr>
@@ -20634,7 +20926,7 @@
       </p:sp>
       <p:sp>
         <p:nvSpPr>
-          <p:cNvPr id="20" name="Oval 19"/>
+          <p:cNvPr id="19" name="Oval 18"/>
           <p:cNvSpPr/>
           <p:nvPr/>
         </p:nvSpPr>
@@ -20678,7 +20970,7 @@
       </p:sp>
       <p:sp>
         <p:nvSpPr>
-          <p:cNvPr id="21" name="TextBox 20"/>
+          <p:cNvPr id="20" name="TextBox 19"/>
           <p:cNvSpPr txBox="1"/>
           <p:nvPr/>
         </p:nvSpPr>
@@ -20725,7 +21017,7 @@
       </p:sp>
       <p:sp>
         <p:nvSpPr>
-          <p:cNvPr id="22" name="TextBox 21"/>
+          <p:cNvPr id="21" name="TextBox 20"/>
           <p:cNvSpPr txBox="1"/>
           <p:nvPr/>
         </p:nvSpPr>
@@ -20772,7 +21064,7 @@
       </p:sp>
       <p:sp>
         <p:nvSpPr>
-          <p:cNvPr id="23" name="Rounded Rectangle 22"/>
+          <p:cNvPr id="22" name="Rounded Rectangle 21"/>
           <p:cNvSpPr/>
           <p:nvPr/>
         </p:nvSpPr>
@@ -20816,7 +21108,7 @@
       </p:sp>
       <p:sp>
         <p:nvSpPr>
-          <p:cNvPr id="24" name="TextBox 23"/>
+          <p:cNvPr id="23" name="TextBox 22"/>
           <p:cNvSpPr txBox="1"/>
           <p:nvPr/>
         </p:nvSpPr>
@@ -20863,7 +21155,7 @@
       </p:sp>
       <p:sp>
         <p:nvSpPr>
-          <p:cNvPr id="25" name="TextBox 24"/>
+          <p:cNvPr id="24" name="TextBox 23"/>
           <p:cNvSpPr txBox="1"/>
           <p:nvPr/>
         </p:nvSpPr>
@@ -20904,6 +21196,64 @@
                 <a:cs typeface="NanumGothic"/>
               </a:rPr>
               <a:t>발표 가능한 최종 가설 제안 + 분석 노트</a:t>
+            </a:r>
+          </a:p>
+        </p:txBody>
+      </p:sp>
+      <p:sp>
+        <p:nvSpPr>
+          <p:cNvPr id="25" name="TextBox 24"/>
+          <p:cNvSpPr txBox="1"/>
+          <p:nvPr/>
+        </p:nvSpPr>
+        <p:spPr>
+          <a:xfrm>
+            <a:off x="8988552" y="6419088"/>
+            <a:ext cx="2697480" cy="365760"/>
+          </a:xfrm>
+          <a:prstGeom prst="rect">
+            <a:avLst/>
+          </a:prstGeom>
+          <a:noFill/>
+        </p:spPr>
+        <p:txBody>
+          <a:bodyPr wrap="square" anchor="ctr" lIns="0" rIns="0" tIns="0" bIns="0">
+            <a:spAutoFit/>
+          </a:bodyPr>
+          <a:lstStyle/>
+          <a:p>
+            <a:pPr algn="r">
+              <a:lnSpc>
+                <a:spcPct val="100000"/>
+              </a:lnSpc>
+              <a:spcBef>
+                <a:spcPts val="0"/>
+              </a:spcBef>
+              <a:spcAft>
+                <a:spcPts val="600"/>
+              </a:spcAft>
+            </a:pPr>
+            <a:r>
+              <a:rPr sz="900" b="1">
+                <a:solidFill>
+                  <a:srgbClr val="F43F5E"/>
+                </a:solidFill>
+                <a:latin typeface="NanumGothic"/>
+                <a:ea typeface="NanumGothic"/>
+                <a:cs typeface="NanumGothic"/>
+              </a:rPr>
+              <a:t>Day 5 · 금</a:t>
+            </a:r>
+            <a:r>
+              <a:rPr sz="900" b="1">
+                <a:solidFill>
+                  <a:srgbClr val="64748B"/>
+                </a:solidFill>
+                <a:latin typeface="NanumGothic"/>
+                <a:ea typeface="NanumGothic"/>
+                <a:cs typeface="NanumGothic"/>
+              </a:rPr>
+              <a:t>   ·   7 / 21</a:t>
             </a:r>
           </a:p>
         </p:txBody>
@@ -21201,54 +21551,7 @@
       </p:sp>
       <p:sp>
         <p:nvSpPr>
-          <p:cNvPr id="8" name="TextBox 7"/>
-          <p:cNvSpPr txBox="1"/>
-          <p:nvPr/>
-        </p:nvSpPr>
-        <p:spPr>
-          <a:xfrm>
-            <a:off x="10241280" y="6419088"/>
-            <a:ext cx="1463040" cy="365760"/>
-          </a:xfrm>
-          <a:prstGeom prst="rect">
-            <a:avLst/>
-          </a:prstGeom>
-          <a:noFill/>
-        </p:spPr>
-        <p:txBody>
-          <a:bodyPr wrap="square" anchor="ctr" lIns="0" rIns="0" tIns="0" bIns="0">
-            <a:spAutoFit/>
-          </a:bodyPr>
-          <a:lstStyle/>
-          <a:p>
-            <a:pPr algn="r">
-              <a:lnSpc>
-                <a:spcPct val="100000"/>
-              </a:lnSpc>
-              <a:spcBef>
-                <a:spcPts val="0"/>
-              </a:spcBef>
-              <a:spcAft>
-                <a:spcPts val="600"/>
-              </a:spcAft>
-            </a:pPr>
-            <a:r>
-              <a:rPr sz="900" b="1">
-                <a:solidFill>
-                  <a:srgbClr val="F43F5E"/>
-                </a:solidFill>
-                <a:latin typeface="NanumGothic"/>
-                <a:ea typeface="NanumGothic"/>
-                <a:cs typeface="NanumGothic"/>
-              </a:rPr>
-              <a:t>Day 5 · 금</a:t>
-            </a:r>
-          </a:p>
-        </p:txBody>
-      </p:sp>
-      <p:sp>
-        <p:nvSpPr>
-          <p:cNvPr id="9" name="Oval 8"/>
+          <p:cNvPr id="8" name="Oval 7"/>
           <p:cNvSpPr/>
           <p:nvPr/>
         </p:nvSpPr>
@@ -21292,7 +21595,7 @@
       </p:sp>
       <p:sp>
         <p:nvSpPr>
-          <p:cNvPr id="10" name="TextBox 9"/>
+          <p:cNvPr id="9" name="TextBox 8"/>
           <p:cNvSpPr txBox="1"/>
           <p:nvPr/>
         </p:nvSpPr>
@@ -21339,7 +21642,7 @@
       </p:sp>
       <p:sp>
         <p:nvSpPr>
-          <p:cNvPr id="11" name="TextBox 10"/>
+          <p:cNvPr id="10" name="TextBox 9"/>
           <p:cNvSpPr txBox="1"/>
           <p:nvPr/>
         </p:nvSpPr>
@@ -21386,7 +21689,7 @@
       </p:sp>
       <p:sp>
         <p:nvSpPr>
-          <p:cNvPr id="12" name="Oval 11"/>
+          <p:cNvPr id="11" name="Oval 10"/>
           <p:cNvSpPr/>
           <p:nvPr/>
         </p:nvSpPr>
@@ -21430,7 +21733,7 @@
       </p:sp>
       <p:sp>
         <p:nvSpPr>
-          <p:cNvPr id="13" name="TextBox 12"/>
+          <p:cNvPr id="12" name="TextBox 11"/>
           <p:cNvSpPr txBox="1"/>
           <p:nvPr/>
         </p:nvSpPr>
@@ -21477,7 +21780,7 @@
       </p:sp>
       <p:sp>
         <p:nvSpPr>
-          <p:cNvPr id="14" name="TextBox 13"/>
+          <p:cNvPr id="13" name="TextBox 12"/>
           <p:cNvSpPr txBox="1"/>
           <p:nvPr/>
         </p:nvSpPr>
@@ -21524,7 +21827,7 @@
       </p:sp>
       <p:sp>
         <p:nvSpPr>
-          <p:cNvPr id="15" name="Oval 14"/>
+          <p:cNvPr id="14" name="Oval 13"/>
           <p:cNvSpPr/>
           <p:nvPr/>
         </p:nvSpPr>
@@ -21568,7 +21871,7 @@
       </p:sp>
       <p:sp>
         <p:nvSpPr>
-          <p:cNvPr id="16" name="TextBox 15"/>
+          <p:cNvPr id="15" name="TextBox 14"/>
           <p:cNvSpPr txBox="1"/>
           <p:nvPr/>
         </p:nvSpPr>
@@ -21615,7 +21918,7 @@
       </p:sp>
       <p:sp>
         <p:nvSpPr>
-          <p:cNvPr id="17" name="TextBox 16"/>
+          <p:cNvPr id="16" name="TextBox 15"/>
           <p:cNvSpPr txBox="1"/>
           <p:nvPr/>
         </p:nvSpPr>
@@ -21656,6 +21959,64 @@
                 <a:cs typeface="NanumGothic"/>
               </a:rPr>
               <a:t>정직한 제안</a:t>
+            </a:r>
+          </a:p>
+        </p:txBody>
+      </p:sp>
+      <p:sp>
+        <p:nvSpPr>
+          <p:cNvPr id="17" name="TextBox 16"/>
+          <p:cNvSpPr txBox="1"/>
+          <p:nvPr/>
+        </p:nvSpPr>
+        <p:spPr>
+          <a:xfrm>
+            <a:off x="8988552" y="6419088"/>
+            <a:ext cx="2697480" cy="365760"/>
+          </a:xfrm>
+          <a:prstGeom prst="rect">
+            <a:avLst/>
+          </a:prstGeom>
+          <a:noFill/>
+        </p:spPr>
+        <p:txBody>
+          <a:bodyPr wrap="square" anchor="ctr" lIns="0" rIns="0" tIns="0" bIns="0">
+            <a:spAutoFit/>
+          </a:bodyPr>
+          <a:lstStyle/>
+          <a:p>
+            <a:pPr algn="r">
+              <a:lnSpc>
+                <a:spcPct val="100000"/>
+              </a:lnSpc>
+              <a:spcBef>
+                <a:spcPts val="0"/>
+              </a:spcBef>
+              <a:spcAft>
+                <a:spcPts val="600"/>
+              </a:spcAft>
+            </a:pPr>
+            <a:r>
+              <a:rPr sz="900" b="1">
+                <a:solidFill>
+                  <a:srgbClr val="F43F5E"/>
+                </a:solidFill>
+                <a:latin typeface="NanumGothic"/>
+                <a:ea typeface="NanumGothic"/>
+                <a:cs typeface="NanumGothic"/>
+              </a:rPr>
+              <a:t>Day 5 · 금</a:t>
+            </a:r>
+            <a:r>
+              <a:rPr sz="900" b="1">
+                <a:solidFill>
+                  <a:srgbClr val="64748B"/>
+                </a:solidFill>
+                <a:latin typeface="NanumGothic"/>
+                <a:ea typeface="NanumGothic"/>
+                <a:cs typeface="NanumGothic"/>
+              </a:rPr>
+              <a:t>   ·   8 / 21</a:t>
             </a:r>
           </a:p>
         </p:txBody>
@@ -21959,6 +22320,64 @@
           <a:lstStyle/>
           <a:p>
             <a:pPr algn="ctr"/>
+          </a:p>
+        </p:txBody>
+      </p:sp>
+      <p:sp>
+        <p:nvSpPr>
+          <p:cNvPr id="8" name="TextBox 7"/>
+          <p:cNvSpPr txBox="1"/>
+          <p:nvPr/>
+        </p:nvSpPr>
+        <p:spPr>
+          <a:xfrm>
+            <a:off x="8988552" y="6419088"/>
+            <a:ext cx="2697480" cy="365760"/>
+          </a:xfrm>
+          <a:prstGeom prst="rect">
+            <a:avLst/>
+          </a:prstGeom>
+          <a:noFill/>
+        </p:spPr>
+        <p:txBody>
+          <a:bodyPr wrap="square" anchor="ctr" lIns="0" rIns="0" tIns="0" bIns="0">
+            <a:spAutoFit/>
+          </a:bodyPr>
+          <a:lstStyle/>
+          <a:p>
+            <a:pPr algn="r">
+              <a:lnSpc>
+                <a:spcPct val="100000"/>
+              </a:lnSpc>
+              <a:spcBef>
+                <a:spcPts val="0"/>
+              </a:spcBef>
+              <a:spcAft>
+                <a:spcPts val="600"/>
+              </a:spcAft>
+            </a:pPr>
+            <a:r>
+              <a:rPr sz="900" b="1">
+                <a:solidFill>
+                  <a:srgbClr val="F43F5E"/>
+                </a:solidFill>
+                <a:latin typeface="NanumGothic"/>
+                <a:ea typeface="NanumGothic"/>
+                <a:cs typeface="NanumGothic"/>
+              </a:rPr>
+              <a:t>Day 5 · 금</a:t>
+            </a:r>
+            <a:r>
+              <a:rPr sz="900" b="1">
+                <a:solidFill>
+                  <a:srgbClr val="CBD5E1"/>
+                </a:solidFill>
+                <a:latin typeface="NanumGothic"/>
+                <a:ea typeface="NanumGothic"/>
+                <a:cs typeface="NanumGothic"/>
+              </a:rPr>
+              <a:t>   ·   9 / 21</a:t>
+            </a:r>
           </a:p>
         </p:txBody>
       </p:sp>

</xml_diff>